<commit_message>
docs: present domain packages as proposed use cases, drop status column
Co-Authored-By: Claude Fable 5.1 <noreply@anthropic.com>
</commit_message>
<xml_diff>
--- a/docs/webcash-ai-gateway-concept-visual.pptx
+++ b/docs/webcash-ai-gateway-concept-visual.pptx
@@ -6562,7 +6562,7 @@
                 <a:ea typeface="Calibri" pitchFamily="34" charset="-122"/>
                 <a:cs typeface="Calibri" pitchFamily="34" charset="-120"/>
               </a:rPr>
-              <a:t>Domain packages and what customers ask</a:t>
+              <a:t>Proposed use cases: domain packages and what customers ask</a:t>
             </a:r>
             <a:endParaRPr lang="en-US" sz="2400" dirty="0"/>
           </a:p>
@@ -6601,7 +6601,7 @@
                 <a:ea typeface="Calibri" pitchFamily="34" charset="-122"/>
                 <a:cs typeface="Calibri" pitchFamily="34" charset="-120"/>
               </a:rPr>
-              <a:t>Each package is a set of products activated together. The first is running; the others reuse the same registration path.</a:t>
+              <a:t>Each package is a set of products activated together. These are the use cases we propose; each one is delivered through the same registry and control model.</a:t>
             </a:r>
             <a:endParaRPr lang="en-US" sz="1100" dirty="0"/>
           </a:p>
@@ -6630,11 +6630,10 @@
             <a:tbl>
               <a:tblPr/>
               <a:tblGrid>
-                <a:gridCol w="1554480"/>
-                <a:gridCol w="1600200"/>
-                <a:gridCol w="3200400"/>
-                <a:gridCol w="1051560"/>
-                <a:gridCol w="914400"/>
+                <a:gridCol w="1645920"/>
+                <a:gridCol w="1828800"/>
+                <a:gridCol w="3474720"/>
+                <a:gridCol w="1371600"/>
               </a:tblGrid>
               <a:tr h="292608">
                 <a:tc>
@@ -6858,75 +6857,7 @@
                           <a:ea typeface="Calibri" pitchFamily="34" charset="-122"/>
                           <a:cs typeface="Calibri" pitchFamily="34" charset="-120"/>
                         </a:rPr>
-                        <a:t>Tier</a:t>
-                      </a:r>
-                      <a:endParaRPr lang="en-US" sz="900" dirty="0">
-                        <a:latin typeface="Calibri" charset="0"/>
-                        <a:ea typeface="Calibri" charset="0"/>
-                        <a:cs typeface="Calibri" charset="0"/>
-                      </a:endParaRPr>
-                    </a:p>
-                  </a:txBody>
-                  <a:tcPr marL="54864" marR="54864" marT="54864" marB="54864" anchor="ctr">
-                    <a:lnL w="9525" cap="flat" cmpd="sng" algn="ctr">
-                      <a:solidFill>
-                        <a:srgbClr val="D9E0EA"/>
-                      </a:solidFill>
-                      <a:prstDash val="solid"/>
-                      <a:round/>
-                      <a:headEnd type="none" w="med" len="med"/>
-                      <a:tailEnd type="none" w="med" len="med"/>
-                    </a:lnL>
-                    <a:lnR w="9525" cap="flat" cmpd="sng" algn="ctr">
-                      <a:solidFill>
-                        <a:srgbClr val="D9E0EA"/>
-                      </a:solidFill>
-                      <a:prstDash val="solid"/>
-                      <a:round/>
-                      <a:headEnd type="none" w="med" len="med"/>
-                      <a:tailEnd type="none" w="med" len="med"/>
-                    </a:lnR>
-                    <a:lnT w="9525" cap="flat" cmpd="sng" algn="ctr">
-                      <a:solidFill>
-                        <a:srgbClr val="D9E0EA"/>
-                      </a:solidFill>
-                      <a:prstDash val="solid"/>
-                      <a:round/>
-                      <a:headEnd type="none" w="med" len="med"/>
-                      <a:tailEnd type="none" w="med" len="med"/>
-                    </a:lnT>
-                    <a:lnB w="9525" cap="flat" cmpd="sng" algn="ctr">
-                      <a:solidFill>
-                        <a:srgbClr val="D9E0EA"/>
-                      </a:solidFill>
-                      <a:prstDash val="solid"/>
-                      <a:round/>
-                      <a:headEnd type="none" w="med" len="med"/>
-                      <a:tailEnd type="none" w="med" len="med"/>
-                    </a:lnB>
-                    <a:solidFill>
-                      <a:srgbClr val="14213D"/>
-                    </a:solidFill>
-                  </a:tcPr>
-                </a:tc>
-                <a:tc>
-                  <a:txBody>
-                    <a:bodyPr/>
-                    <a:lstStyle/>
-                    <a:p>
-                      <a:pPr indent="0" marL="0">
-                        <a:buNone/>
-                      </a:pPr>
-                      <a:r>
-                        <a:rPr lang="en-US" sz="900" b="1" dirty="0">
-                          <a:solidFill>
-                            <a:srgbClr val="FFFFFF"/>
-                          </a:solidFill>
-                          <a:latin typeface="Calibri" pitchFamily="34" charset="0"/>
-                          <a:ea typeface="Calibri" pitchFamily="34" charset="-122"/>
-                          <a:cs typeface="Calibri" pitchFamily="34" charset="-120"/>
-                        </a:rPr>
-                        <a:t>Status</a:t>
+                        <a:t>Control tier</a:t>
                       </a:r>
                       <a:endParaRPr lang="en-US" sz="900" dirty="0">
                         <a:latin typeface="Calibri" charset="0"/>
@@ -7239,71 +7170,6 @@
                     </a:lnB>
                   </a:tcPr>
                 </a:tc>
-                <a:tc>
-                  <a:txBody>
-                    <a:bodyPr/>
-                    <a:lstStyle/>
-                    <a:p>
-                      <a:pPr indent="0" marL="0">
-                        <a:buNone/>
-                      </a:pPr>
-                      <a:r>
-                        <a:rPr lang="en-US" sz="830" dirty="0">
-                          <a:solidFill>
-                            <a:srgbClr val="4A5568"/>
-                          </a:solidFill>
-                          <a:latin typeface="Calibri" pitchFamily="34" charset="0"/>
-                          <a:ea typeface="Calibri" pitchFamily="34" charset="-122"/>
-                          <a:cs typeface="Calibri" pitchFamily="34" charset="-120"/>
-                        </a:rPr>
-                        <a:t>Running (pilot)</a:t>
-                      </a:r>
-                      <a:endParaRPr lang="en-US" sz="830" dirty="0">
-                        <a:latin typeface="Calibri" charset="0"/>
-                        <a:ea typeface="Calibri" charset="0"/>
-                        <a:cs typeface="Calibri" charset="0"/>
-                      </a:endParaRPr>
-                    </a:p>
-                  </a:txBody>
-                  <a:tcPr marL="54864" marR="54864" marT="54864" marB="54864" anchor="ctr">
-                    <a:lnL w="9525" cap="flat" cmpd="sng" algn="ctr">
-                      <a:solidFill>
-                        <a:srgbClr val="D9E0EA"/>
-                      </a:solidFill>
-                      <a:prstDash val="solid"/>
-                      <a:round/>
-                      <a:headEnd type="none" w="med" len="med"/>
-                      <a:tailEnd type="none" w="med" len="med"/>
-                    </a:lnL>
-                    <a:lnR w="9525" cap="flat" cmpd="sng" algn="ctr">
-                      <a:solidFill>
-                        <a:srgbClr val="D9E0EA"/>
-                      </a:solidFill>
-                      <a:prstDash val="solid"/>
-                      <a:round/>
-                      <a:headEnd type="none" w="med" len="med"/>
-                      <a:tailEnd type="none" w="med" len="med"/>
-                    </a:lnR>
-                    <a:lnT w="9525" cap="flat" cmpd="sng" algn="ctr">
-                      <a:solidFill>
-                        <a:srgbClr val="D9E0EA"/>
-                      </a:solidFill>
-                      <a:prstDash val="solid"/>
-                      <a:round/>
-                      <a:headEnd type="none" w="med" len="med"/>
-                      <a:tailEnd type="none" w="med" len="med"/>
-                    </a:lnT>
-                    <a:lnB w="9525" cap="flat" cmpd="sng" algn="ctr">
-                      <a:solidFill>
-                        <a:srgbClr val="D9E0EA"/>
-                      </a:solidFill>
-                      <a:prstDash val="solid"/>
-                      <a:round/>
-                      <a:headEnd type="none" w="med" len="med"/>
-                      <a:tailEnd type="none" w="med" len="med"/>
-                    </a:lnB>
-                  </a:tcPr>
-                </a:tc>
               </a:tr>
               <a:tr h="640080">
                 <a:tc>
@@ -7519,71 +7385,6 @@
                           <a:cs typeface="Calibri" pitchFamily="34" charset="-120"/>
                         </a:rPr>
                         <a:t>Lookup · Draft</a:t>
-                      </a:r>
-                      <a:endParaRPr lang="en-US" sz="830" dirty="0">
-                        <a:latin typeface="Calibri" charset="0"/>
-                        <a:ea typeface="Calibri" charset="0"/>
-                        <a:cs typeface="Calibri" charset="0"/>
-                      </a:endParaRPr>
-                    </a:p>
-                  </a:txBody>
-                  <a:tcPr marL="54864" marR="54864" marT="54864" marB="54864" anchor="ctr">
-                    <a:lnL w="9525" cap="flat" cmpd="sng" algn="ctr">
-                      <a:solidFill>
-                        <a:srgbClr val="D9E0EA"/>
-                      </a:solidFill>
-                      <a:prstDash val="solid"/>
-                      <a:round/>
-                      <a:headEnd type="none" w="med" len="med"/>
-                      <a:tailEnd type="none" w="med" len="med"/>
-                    </a:lnL>
-                    <a:lnR w="9525" cap="flat" cmpd="sng" algn="ctr">
-                      <a:solidFill>
-                        <a:srgbClr val="D9E0EA"/>
-                      </a:solidFill>
-                      <a:prstDash val="solid"/>
-                      <a:round/>
-                      <a:headEnd type="none" w="med" len="med"/>
-                      <a:tailEnd type="none" w="med" len="med"/>
-                    </a:lnR>
-                    <a:lnT w="9525" cap="flat" cmpd="sng" algn="ctr">
-                      <a:solidFill>
-                        <a:srgbClr val="D9E0EA"/>
-                      </a:solidFill>
-                      <a:prstDash val="solid"/>
-                      <a:round/>
-                      <a:headEnd type="none" w="med" len="med"/>
-                      <a:tailEnd type="none" w="med" len="med"/>
-                    </a:lnT>
-                    <a:lnB w="9525" cap="flat" cmpd="sng" algn="ctr">
-                      <a:solidFill>
-                        <a:srgbClr val="D9E0EA"/>
-                      </a:solidFill>
-                      <a:prstDash val="solid"/>
-                      <a:round/>
-                      <a:headEnd type="none" w="med" len="med"/>
-                      <a:tailEnd type="none" w="med" len="med"/>
-                    </a:lnB>
-                  </a:tcPr>
-                </a:tc>
-                <a:tc>
-                  <a:txBody>
-                    <a:bodyPr/>
-                    <a:lstStyle/>
-                    <a:p>
-                      <a:pPr indent="0" marL="0">
-                        <a:buNone/>
-                      </a:pPr>
-                      <a:r>
-                        <a:rPr lang="en-US" sz="830" dirty="0">
-                          <a:solidFill>
-                            <a:srgbClr val="4A5568"/>
-                          </a:solidFill>
-                          <a:latin typeface="Calibri" pitchFamily="34" charset="0"/>
-                          <a:ea typeface="Calibri" pitchFamily="34" charset="-122"/>
-                          <a:cs typeface="Calibri" pitchFamily="34" charset="-120"/>
-                        </a:rPr>
-                        <a:t>Next</a:t>
                       </a:r>
                       <a:endParaRPr lang="en-US" sz="830" dirty="0">
                         <a:latin typeface="Calibri" charset="0"/>
@@ -7893,71 +7694,6 @@
                     </a:lnB>
                   </a:tcPr>
                 </a:tc>
-                <a:tc>
-                  <a:txBody>
-                    <a:bodyPr/>
-                    <a:lstStyle/>
-                    <a:p>
-                      <a:pPr indent="0" marL="0">
-                        <a:buNone/>
-                      </a:pPr>
-                      <a:r>
-                        <a:rPr lang="en-US" sz="830" dirty="0">
-                          <a:solidFill>
-                            <a:srgbClr val="4A5568"/>
-                          </a:solidFill>
-                          <a:latin typeface="Calibri" pitchFamily="34" charset="0"/>
-                          <a:ea typeface="Calibri" pitchFamily="34" charset="-122"/>
-                          <a:cs typeface="Calibri" pitchFamily="34" charset="-120"/>
-                        </a:rPr>
-                        <a:t>Next</a:t>
-                      </a:r>
-                      <a:endParaRPr lang="en-US" sz="830" dirty="0">
-                        <a:latin typeface="Calibri" charset="0"/>
-                        <a:ea typeface="Calibri" charset="0"/>
-                        <a:cs typeface="Calibri" charset="0"/>
-                      </a:endParaRPr>
-                    </a:p>
-                  </a:txBody>
-                  <a:tcPr marL="54864" marR="54864" marT="54864" marB="54864" anchor="ctr">
-                    <a:lnL w="9525" cap="flat" cmpd="sng" algn="ctr">
-                      <a:solidFill>
-                        <a:srgbClr val="D9E0EA"/>
-                      </a:solidFill>
-                      <a:prstDash val="solid"/>
-                      <a:round/>
-                      <a:headEnd type="none" w="med" len="med"/>
-                      <a:tailEnd type="none" w="med" len="med"/>
-                    </a:lnL>
-                    <a:lnR w="9525" cap="flat" cmpd="sng" algn="ctr">
-                      <a:solidFill>
-                        <a:srgbClr val="D9E0EA"/>
-                      </a:solidFill>
-                      <a:prstDash val="solid"/>
-                      <a:round/>
-                      <a:headEnd type="none" w="med" len="med"/>
-                      <a:tailEnd type="none" w="med" len="med"/>
-                    </a:lnR>
-                    <a:lnT w="9525" cap="flat" cmpd="sng" algn="ctr">
-                      <a:solidFill>
-                        <a:srgbClr val="D9E0EA"/>
-                      </a:solidFill>
-                      <a:prstDash val="solid"/>
-                      <a:round/>
-                      <a:headEnd type="none" w="med" len="med"/>
-                      <a:tailEnd type="none" w="med" len="med"/>
-                    </a:lnT>
-                    <a:lnB w="9525" cap="flat" cmpd="sng" algn="ctr">
-                      <a:solidFill>
-                        <a:srgbClr val="D9E0EA"/>
-                      </a:solidFill>
-                      <a:prstDash val="solid"/>
-                      <a:round/>
-                      <a:headEnd type="none" w="med" len="med"/>
-                      <a:tailEnd type="none" w="med" len="med"/>
-                    </a:lnB>
-                  </a:tcPr>
-                </a:tc>
               </a:tr>
               <a:tr h="640080">
                 <a:tc>
@@ -8173,71 +7909,6 @@
                           <a:cs typeface="Calibri" pitchFamily="34" charset="-120"/>
                         </a:rPr>
                         <a:t>High control · Rules</a:t>
-                      </a:r>
-                      <a:endParaRPr lang="en-US" sz="830" dirty="0">
-                        <a:latin typeface="Calibri" charset="0"/>
-                        <a:ea typeface="Calibri" charset="0"/>
-                        <a:cs typeface="Calibri" charset="0"/>
-                      </a:endParaRPr>
-                    </a:p>
-                  </a:txBody>
-                  <a:tcPr marL="54864" marR="54864" marT="54864" marB="54864" anchor="ctr">
-                    <a:lnL w="9525" cap="flat" cmpd="sng" algn="ctr">
-                      <a:solidFill>
-                        <a:srgbClr val="D9E0EA"/>
-                      </a:solidFill>
-                      <a:prstDash val="solid"/>
-                      <a:round/>
-                      <a:headEnd type="none" w="med" len="med"/>
-                      <a:tailEnd type="none" w="med" len="med"/>
-                    </a:lnL>
-                    <a:lnR w="9525" cap="flat" cmpd="sng" algn="ctr">
-                      <a:solidFill>
-                        <a:srgbClr val="D9E0EA"/>
-                      </a:solidFill>
-                      <a:prstDash val="solid"/>
-                      <a:round/>
-                      <a:headEnd type="none" w="med" len="med"/>
-                      <a:tailEnd type="none" w="med" len="med"/>
-                    </a:lnR>
-                    <a:lnT w="9525" cap="flat" cmpd="sng" algn="ctr">
-                      <a:solidFill>
-                        <a:srgbClr val="D9E0EA"/>
-                      </a:solidFill>
-                      <a:prstDash val="solid"/>
-                      <a:round/>
-                      <a:headEnd type="none" w="med" len="med"/>
-                      <a:tailEnd type="none" w="med" len="med"/>
-                    </a:lnT>
-                    <a:lnB w="9525" cap="flat" cmpd="sng" algn="ctr">
-                      <a:solidFill>
-                        <a:srgbClr val="D9E0EA"/>
-                      </a:solidFill>
-                      <a:prstDash val="solid"/>
-                      <a:round/>
-                      <a:headEnd type="none" w="med" len="med"/>
-                      <a:tailEnd type="none" w="med" len="med"/>
-                    </a:lnB>
-                  </a:tcPr>
-                </a:tc>
-                <a:tc>
-                  <a:txBody>
-                    <a:bodyPr/>
-                    <a:lstStyle/>
-                    <a:p>
-                      <a:pPr indent="0" marL="0">
-                        <a:buNone/>
-                      </a:pPr>
-                      <a:r>
-                        <a:rPr lang="en-US" sz="830" dirty="0">
-                          <a:solidFill>
-                            <a:srgbClr val="4A5568"/>
-                          </a:solidFill>
-                          <a:latin typeface="Calibri" pitchFamily="34" charset="0"/>
-                          <a:ea typeface="Calibri" pitchFamily="34" charset="-122"/>
-                          <a:cs typeface="Calibri" pitchFamily="34" charset="-120"/>
-                        </a:rPr>
-                        <a:t>Later</a:t>
                       </a:r>
                       <a:endParaRPr lang="en-US" sz="830" dirty="0">
                         <a:latin typeface="Calibri" charset="0"/>

</xml_diff>

<commit_message>
docs: reframe expansion slide as proposed scope with a use case per circle
Co-Authored-By: Claude Fable 5.1 <noreply@anthropic.com>
</commit_message>
<xml_diff>
--- a/docs/webcash-ai-gateway-concept-visual.pptx
+++ b/docs/webcash-ai-gateway-concept-visual.pptx
@@ -8143,7 +8143,7 @@
                 <a:ea typeface="Calibri" pitchFamily="34" charset="-122"/>
                 <a:cs typeface="Calibri" pitchFamily="34" charset="-120"/>
               </a:rPr>
-              <a:t>GROWTH</a:t>
+              <a:t>PROPOSED SCOPE</a:t>
             </a:r>
             <a:endParaRPr lang="en-US" sz="800" dirty="0"/>
           </a:p>
@@ -8182,7 +8182,7 @@
                 <a:ea typeface="Calibri" pitchFamily="34" charset="-122"/>
                 <a:cs typeface="Calibri" pitchFamily="34" charset="-120"/>
               </a:rPr>
-              <a:t>Expansion path</a:t>
+              <a:t>Proposed scope: three circles of connection</a:t>
             </a:r>
             <a:endParaRPr lang="en-US" sz="2400" dirty="0"/>
           </a:p>
@@ -8221,7 +8221,7 @@
                 <a:ea typeface="Calibri" pitchFamily="34" charset="-122"/>
                 <a:cs typeface="Calibri" pitchFamily="34" charset="-120"/>
               </a:rPr>
-              <a:t>Because a registered spec is the whole integration, each further connection costs less than the last.</a:t>
+              <a:t>One registry and one control model serve all three. Each circle adds use cases without adding a new kind of integration.</a:t>
             </a:r>
             <a:endParaRPr lang="en-US" sz="1100" dirty="0"/>
           </a:p>
@@ -8236,11 +8236,11 @@
         <p:spPr>
           <a:xfrm>
             <a:off x="411480" y="1325880"/>
-            <a:ext cx="2651760" cy="2011680"/>
+            <a:ext cx="2651760" cy="2331720"/>
           </a:xfrm>
           <a:prstGeom prst="roundRect">
             <a:avLst>
-              <a:gd name="adj" fmla="val 2727"/>
+              <a:gd name="adj" fmla="val 2353"/>
             </a:avLst>
           </a:prstGeom>
           <a:solidFill>
@@ -8248,7 +8248,7 @@
           </a:solidFill>
           <a:ln w="9525">
             <a:solidFill>
-              <a:srgbClr val="0F766E"/>
+              <a:srgbClr val="D9E0EA"/>
             </a:solidFill>
             <a:prstDash val="solid"/>
           </a:ln>
@@ -8257,6 +8257,70 @@
       <p:sp>
         <p:nvSpPr>
           <p:cNvPr id="6" name="Shape 4"/>
+          <p:cNvSpPr/>
+          <p:nvPr/>
+        </p:nvSpPr>
+        <p:spPr>
+          <a:xfrm>
+            <a:off x="594360" y="2761488"/>
+            <a:ext cx="2286000" cy="9144"/>
+          </a:xfrm>
+          <a:prstGeom prst="rect">
+            <a:avLst/>
+          </a:prstGeom>
+          <a:solidFill>
+            <a:srgbClr val="D9E0EA"/>
+          </a:solidFill>
+          <a:ln w="12700">
+            <a:solidFill>
+              <a:srgbClr val="D9E0EA"/>
+            </a:solidFill>
+            <a:prstDash val="solid"/>
+          </a:ln>
+        </p:spPr>
+      </p:sp>
+      <p:sp>
+        <p:nvSpPr>
+          <p:cNvPr id="7" name="Text 5"/>
+          <p:cNvSpPr txBox="1"/>
+          <p:nvPr/>
+        </p:nvSpPr>
+        <p:spPr>
+          <a:xfrm>
+            <a:off x="594360" y="2834640"/>
+            <a:ext cx="2286000" cy="164592"/>
+          </a:xfrm>
+          <a:prstGeom prst="rect">
+            <a:avLst/>
+          </a:prstGeom>
+          <a:noFill/>
+          <a:ln/>
+        </p:spPr>
+        <p:txBody>
+          <a:bodyPr wrap="square" lIns="0" tIns="0" rIns="0" bIns="0" rtlCol="0" anchor="ctr"/>
+          <a:lstStyle/>
+          <a:p>
+            <a:pPr indent="0" marL="0">
+              <a:buNone/>
+            </a:pPr>
+            <a:r>
+              <a:rPr lang="en-US" sz="700" b="1" spc="100" kern="0" dirty="0">
+                <a:solidFill>
+                  <a:srgbClr val="0F766E"/>
+                </a:solidFill>
+                <a:latin typeface="Calibri" pitchFamily="34" charset="0"/>
+                <a:ea typeface="Calibri" pitchFamily="34" charset="-122"/>
+                <a:cs typeface="Calibri" pitchFamily="34" charset="-120"/>
+              </a:rPr>
+              <a:t>PROPOSED USE CASE</a:t>
+            </a:r>
+            <a:endParaRPr lang="en-US" sz="700" dirty="0"/>
+          </a:p>
+        </p:txBody>
+      </p:sp>
+      <p:sp>
+        <p:nvSpPr>
+          <p:cNvPr id="8" name="Shape 6"/>
           <p:cNvSpPr/>
           <p:nvPr/>
         </p:nvSpPr>
@@ -8281,7 +8345,7 @@
       </p:sp>
       <p:sp>
         <p:nvSpPr>
-          <p:cNvPr id="7" name="Text 5"/>
+          <p:cNvPr id="9" name="Text 7"/>
           <p:cNvSpPr txBox="1"/>
           <p:nvPr/>
         </p:nvSpPr>
@@ -8320,7 +8384,7 @@
       </p:sp>
       <p:sp>
         <p:nvSpPr>
-          <p:cNvPr id="8" name="Text 6"/>
+          <p:cNvPr id="10" name="Text 8"/>
           <p:cNvSpPr txBox="1"/>
           <p:nvPr/>
         </p:nvSpPr>
@@ -8359,14 +8423,14 @@
       </p:sp>
       <p:sp>
         <p:nvSpPr>
-          <p:cNvPr id="9" name="Text 7"/>
+          <p:cNvPr id="11" name="Text 9"/>
           <p:cNvSpPr txBox="1"/>
           <p:nvPr/>
         </p:nvSpPr>
         <p:spPr>
           <a:xfrm>
             <a:off x="594360" y="2011680"/>
-            <a:ext cx="2286000" cy="960120"/>
+            <a:ext cx="2286000" cy="713232"/>
           </a:xfrm>
           <a:prstGeom prst="rect">
             <a:avLst/>
@@ -8398,46 +8462,46 @@
       </p:sp>
       <p:sp>
         <p:nvSpPr>
-          <p:cNvPr id="10" name="Text 8"/>
-          <p:cNvSpPr txBox="1"/>
-          <p:nvPr/>
-        </p:nvSpPr>
-        <p:spPr>
-          <a:xfrm>
-            <a:off x="594360" y="3035808"/>
-            <a:ext cx="2286000" cy="228600"/>
-          </a:xfrm>
-          <a:prstGeom prst="rect">
-            <a:avLst/>
-          </a:prstGeom>
-          <a:noFill/>
-          <a:ln/>
-        </p:spPr>
-        <p:txBody>
-          <a:bodyPr wrap="square" lIns="0" tIns="0" rIns="0" bIns="0" rtlCol="0" anchor="ctr"/>
-          <a:lstStyle/>
-          <a:p>
-            <a:pPr indent="0" marL="0">
-              <a:buNone/>
-            </a:pPr>
-            <a:r>
-              <a:rPr lang="en-US" sz="800" b="1" spc="100" kern="0" dirty="0">
-                <a:solidFill>
-                  <a:srgbClr val="0F766E"/>
-                </a:solidFill>
-                <a:latin typeface="Calibri" pitchFamily="34" charset="0"/>
-                <a:ea typeface="Calibri" pitchFamily="34" charset="-122"/>
-                <a:cs typeface="Calibri" pitchFamily="34" charset="-120"/>
-              </a:rPr>
-              <a:t>now</a:t>
-            </a:r>
-            <a:endParaRPr lang="en-US" sz="800" dirty="0"/>
-          </a:p>
-        </p:txBody>
-      </p:sp>
-      <p:sp>
-        <p:nvSpPr>
-          <p:cNvPr id="11" name="Shape 9"/>
+          <p:cNvPr id="12" name="Text 10"/>
+          <p:cNvSpPr txBox="1"/>
+          <p:nvPr/>
+        </p:nvSpPr>
+        <p:spPr>
+          <a:xfrm>
+            <a:off x="594360" y="3017520"/>
+            <a:ext cx="2286000" cy="566928"/>
+          </a:xfrm>
+          <a:prstGeom prst="rect">
+            <a:avLst/>
+          </a:prstGeom>
+          <a:noFill/>
+          <a:ln/>
+        </p:spPr>
+        <p:txBody>
+          <a:bodyPr wrap="square" lIns="0" tIns="0" rIns="0" bIns="0" rtlCol="0" anchor="ctr"/>
+          <a:lstStyle/>
+          <a:p>
+            <a:pPr indent="0" marL="0">
+              <a:buNone/>
+            </a:pPr>
+            <a:r>
+              <a:rPr lang="en-US" sz="850" i="1" dirty="0">
+                <a:solidFill>
+                  <a:srgbClr val="1C2433"/>
+                </a:solidFill>
+                <a:latin typeface="Calibri" pitchFamily="34" charset="0"/>
+                <a:ea typeface="Calibri" pitchFamily="34" charset="-122"/>
+                <a:cs typeface="Calibri" pitchFamily="34" charset="-120"/>
+              </a:rPr>
+              <a:t>“Find this month's items missing receipts, verify the payees in COOCON, and ask the teams in FLOW to act.”</a:t>
+            </a:r>
+            <a:endParaRPr lang="en-US" sz="850" dirty="0"/>
+          </a:p>
+        </p:txBody>
+      </p:sp>
+      <p:sp>
+        <p:nvSpPr>
+          <p:cNvPr id="13" name="Shape 11"/>
           <p:cNvSpPr/>
           <p:nvPr/>
         </p:nvSpPr>
@@ -8462,18 +8526,587 @@
       </p:sp>
       <p:sp>
         <p:nvSpPr>
-          <p:cNvPr id="12" name="Shape 10"/>
+          <p:cNvPr id="14" name="Shape 12"/>
           <p:cNvSpPr/>
           <p:nvPr/>
         </p:nvSpPr>
         <p:spPr>
           <a:xfrm>
             <a:off x="3246120" y="1325880"/>
-            <a:ext cx="2651760" cy="2011680"/>
+            <a:ext cx="2651760" cy="2331720"/>
           </a:xfrm>
           <a:prstGeom prst="roundRect">
             <a:avLst>
-              <a:gd name="adj" fmla="val 2727"/>
+              <a:gd name="adj" fmla="val 2353"/>
+            </a:avLst>
+          </a:prstGeom>
+          <a:solidFill>
+            <a:srgbClr val="FFFFFF"/>
+          </a:solidFill>
+          <a:ln w="9525">
+            <a:solidFill>
+              <a:srgbClr val="D9E0EA"/>
+            </a:solidFill>
+            <a:prstDash val="solid"/>
+          </a:ln>
+        </p:spPr>
+      </p:sp>
+      <p:sp>
+        <p:nvSpPr>
+          <p:cNvPr id="15" name="Shape 13"/>
+          <p:cNvSpPr/>
+          <p:nvPr/>
+        </p:nvSpPr>
+        <p:spPr>
+          <a:xfrm>
+            <a:off x="3429000" y="2761488"/>
+            <a:ext cx="2286000" cy="9144"/>
+          </a:xfrm>
+          <a:prstGeom prst="rect">
+            <a:avLst/>
+          </a:prstGeom>
+          <a:solidFill>
+            <a:srgbClr val="D9E0EA"/>
+          </a:solidFill>
+          <a:ln w="12700">
+            <a:solidFill>
+              <a:srgbClr val="D9E0EA"/>
+            </a:solidFill>
+            <a:prstDash val="solid"/>
+          </a:ln>
+        </p:spPr>
+      </p:sp>
+      <p:sp>
+        <p:nvSpPr>
+          <p:cNvPr id="16" name="Text 14"/>
+          <p:cNvSpPr txBox="1"/>
+          <p:nvPr/>
+        </p:nvSpPr>
+        <p:spPr>
+          <a:xfrm>
+            <a:off x="3429000" y="2834640"/>
+            <a:ext cx="2286000" cy="164592"/>
+          </a:xfrm>
+          <a:prstGeom prst="rect">
+            <a:avLst/>
+          </a:prstGeom>
+          <a:noFill/>
+          <a:ln/>
+        </p:spPr>
+        <p:txBody>
+          <a:bodyPr wrap="square" lIns="0" tIns="0" rIns="0" bIns="0" rtlCol="0" anchor="ctr"/>
+          <a:lstStyle/>
+          <a:p>
+            <a:pPr indent="0" marL="0">
+              <a:buNone/>
+            </a:pPr>
+            <a:r>
+              <a:rPr lang="en-US" sz="700" b="1" spc="100" kern="0" dirty="0">
+                <a:solidFill>
+                  <a:srgbClr val="14213D"/>
+                </a:solidFill>
+                <a:latin typeface="Calibri" pitchFamily="34" charset="0"/>
+                <a:ea typeface="Calibri" pitchFamily="34" charset="-122"/>
+                <a:cs typeface="Calibri" pitchFamily="34" charset="-120"/>
+              </a:rPr>
+              <a:t>PROPOSED USE CASE</a:t>
+            </a:r>
+            <a:endParaRPr lang="en-US" sz="700" dirty="0"/>
+          </a:p>
+        </p:txBody>
+      </p:sp>
+      <p:sp>
+        <p:nvSpPr>
+          <p:cNvPr id="17" name="Shape 15"/>
+          <p:cNvSpPr/>
+          <p:nvPr/>
+        </p:nvSpPr>
+        <p:spPr>
+          <a:xfrm>
+            <a:off x="3429000" y="1508760"/>
+            <a:ext cx="384048" cy="384048"/>
+          </a:xfrm>
+          <a:prstGeom prst="ellipse">
+            <a:avLst/>
+          </a:prstGeom>
+          <a:solidFill>
+            <a:srgbClr val="14213D"/>
+          </a:solidFill>
+          <a:ln w="12700">
+            <a:solidFill>
+              <a:srgbClr val="14213D"/>
+            </a:solidFill>
+            <a:prstDash val="solid"/>
+          </a:ln>
+        </p:spPr>
+      </p:sp>
+      <p:sp>
+        <p:nvSpPr>
+          <p:cNvPr id="18" name="Text 16"/>
+          <p:cNvSpPr txBox="1"/>
+          <p:nvPr/>
+        </p:nvSpPr>
+        <p:spPr>
+          <a:xfrm>
+            <a:off x="3429000" y="1508760"/>
+            <a:ext cx="384048" cy="384048"/>
+          </a:xfrm>
+          <a:prstGeom prst="rect">
+            <a:avLst/>
+          </a:prstGeom>
+          <a:noFill/>
+          <a:ln/>
+        </p:spPr>
+        <p:txBody>
+          <a:bodyPr wrap="square" lIns="0" tIns="0" rIns="0" bIns="0" rtlCol="0" anchor="ctr"/>
+          <a:lstStyle/>
+          <a:p>
+            <a:pPr algn="ctr" indent="0" marL="0">
+              <a:buNone/>
+            </a:pPr>
+            <a:r>
+              <a:rPr lang="en-US" sz="1300" b="1" dirty="0">
+                <a:solidFill>
+                  <a:srgbClr val="FFFFFF"/>
+                </a:solidFill>
+                <a:latin typeface="Calibri" pitchFamily="34" charset="0"/>
+                <a:ea typeface="Calibri" pitchFamily="34" charset="-122"/>
+                <a:cs typeface="Calibri" pitchFamily="34" charset="-120"/>
+              </a:rPr>
+              <a:t>2</a:t>
+            </a:r>
+            <a:endParaRPr lang="en-US" sz="1300" dirty="0"/>
+          </a:p>
+        </p:txBody>
+      </p:sp>
+      <p:sp>
+        <p:nvSpPr>
+          <p:cNvPr id="19" name="Text 17"/>
+          <p:cNvSpPr txBox="1"/>
+          <p:nvPr/>
+        </p:nvSpPr>
+        <p:spPr>
+          <a:xfrm>
+            <a:off x="3931920" y="1508760"/>
+            <a:ext cx="1828800" cy="384048"/>
+          </a:xfrm>
+          <a:prstGeom prst="rect">
+            <a:avLst/>
+          </a:prstGeom>
+          <a:noFill/>
+          <a:ln/>
+        </p:spPr>
+        <p:txBody>
+          <a:bodyPr wrap="square" lIns="0" tIns="0" rIns="0" bIns="0" rtlCol="0" anchor="ctr"/>
+          <a:lstStyle/>
+          <a:p>
+            <a:pPr indent="0" marL="0">
+              <a:buNone/>
+            </a:pPr>
+            <a:r>
+              <a:rPr lang="en-US" sz="1300" b="1" dirty="0">
+                <a:solidFill>
+                  <a:srgbClr val="1C2433"/>
+                </a:solidFill>
+                <a:latin typeface="Calibri" pitchFamily="34" charset="0"/>
+                <a:ea typeface="Calibri" pitchFamily="34" charset="-122"/>
+                <a:cs typeface="Calibri" pitchFamily="34" charset="-120"/>
+              </a:rPr>
+              <a:t>Partner SaaS</a:t>
+            </a:r>
+            <a:endParaRPr lang="en-US" sz="1300" dirty="0"/>
+          </a:p>
+        </p:txBody>
+      </p:sp>
+      <p:sp>
+        <p:nvSpPr>
+          <p:cNvPr id="20" name="Text 18"/>
+          <p:cNvSpPr txBox="1"/>
+          <p:nvPr/>
+        </p:nvSpPr>
+        <p:spPr>
+          <a:xfrm>
+            <a:off x="3429000" y="2011680"/>
+            <a:ext cx="2286000" cy="713232"/>
+          </a:xfrm>
+          <a:prstGeom prst="rect">
+            <a:avLst/>
+          </a:prstGeom>
+          <a:noFill/>
+          <a:ln/>
+        </p:spPr>
+        <p:txBody>
+          <a:bodyPr wrap="square" lIns="0" tIns="0" rIns="0" bIns="0" rtlCol="0" anchor="ctr"/>
+          <a:lstStyle/>
+          <a:p>
+            <a:pPr indent="0" marL="0">
+              <a:buNone/>
+            </a:pPr>
+            <a:r>
+              <a:rPr lang="en-US" sz="850" dirty="0">
+                <a:solidFill>
+                  <a:srgbClr val="4A5568"/>
+                </a:solidFill>
+                <a:latin typeface="Calibri" pitchFamily="34" charset="0"/>
+                <a:ea typeface="Calibri" pitchFamily="34" charset="-122"/>
+                <a:cs typeface="Calibri" pitchFamily="34" charset="-120"/>
+              </a:rPr>
+              <a:t>ERP, HR, groupware, tax. Registered in the same registry, governed by the same policy, so a customer's whole workflow completes in one place.</a:t>
+            </a:r>
+            <a:endParaRPr lang="en-US" sz="850" dirty="0"/>
+          </a:p>
+        </p:txBody>
+      </p:sp>
+      <p:sp>
+        <p:nvSpPr>
+          <p:cNvPr id="21" name="Text 19"/>
+          <p:cNvSpPr txBox="1"/>
+          <p:nvPr/>
+        </p:nvSpPr>
+        <p:spPr>
+          <a:xfrm>
+            <a:off x="3429000" y="3017520"/>
+            <a:ext cx="2286000" cy="566928"/>
+          </a:xfrm>
+          <a:prstGeom prst="rect">
+            <a:avLst/>
+          </a:prstGeom>
+          <a:noFill/>
+          <a:ln/>
+        </p:spPr>
+        <p:txBody>
+          <a:bodyPr wrap="square" lIns="0" tIns="0" rIns="0" bIns="0" rtlCol="0" anchor="ctr"/>
+          <a:lstStyle/>
+          <a:p>
+            <a:pPr indent="0" marL="0">
+              <a:buNone/>
+            </a:pPr>
+            <a:r>
+              <a:rPr lang="en-US" sz="850" i="1" dirty="0">
+                <a:solidFill>
+                  <a:srgbClr val="1C2433"/>
+                </a:solidFill>
+                <a:latin typeface="Calibri" pitchFamily="34" charset="0"/>
+                <a:ea typeface="Calibri" pitchFamily="34" charset="-122"/>
+                <a:cs typeface="Calibri" pitchFamily="34" charset="-120"/>
+              </a:rPr>
+              <a:t>“Close the month: pull payroll from the HR system, match it to the bank records, and draft the tax filing.”</a:t>
+            </a:r>
+            <a:endParaRPr lang="en-US" sz="850" dirty="0"/>
+          </a:p>
+        </p:txBody>
+      </p:sp>
+      <p:sp>
+        <p:nvSpPr>
+          <p:cNvPr id="22" name="Shape 20"/>
+          <p:cNvSpPr/>
+          <p:nvPr/>
+        </p:nvSpPr>
+        <p:spPr>
+          <a:xfrm>
+            <a:off x="5925312" y="2212848"/>
+            <a:ext cx="128016" cy="219456"/>
+          </a:xfrm>
+          <a:prstGeom prst="rightArrow">
+            <a:avLst/>
+          </a:prstGeom>
+          <a:solidFill>
+            <a:srgbClr val="7A8593"/>
+          </a:solidFill>
+          <a:ln w="12700">
+            <a:solidFill>
+              <a:srgbClr val="7A8593"/>
+            </a:solidFill>
+            <a:prstDash val="solid"/>
+          </a:ln>
+        </p:spPr>
+      </p:sp>
+      <p:sp>
+        <p:nvSpPr>
+          <p:cNvPr id="23" name="Shape 21"/>
+          <p:cNvSpPr/>
+          <p:nvPr/>
+        </p:nvSpPr>
+        <p:spPr>
+          <a:xfrm>
+            <a:off x="6080760" y="1325880"/>
+            <a:ext cx="2651760" cy="2331720"/>
+          </a:xfrm>
+          <a:prstGeom prst="roundRect">
+            <a:avLst>
+              <a:gd name="adj" fmla="val 2353"/>
+            </a:avLst>
+          </a:prstGeom>
+          <a:solidFill>
+            <a:srgbClr val="FFFFFF"/>
+          </a:solidFill>
+          <a:ln w="9525">
+            <a:solidFill>
+              <a:srgbClr val="D9E0EA"/>
+            </a:solidFill>
+            <a:prstDash val="solid"/>
+          </a:ln>
+        </p:spPr>
+      </p:sp>
+      <p:sp>
+        <p:nvSpPr>
+          <p:cNvPr id="24" name="Shape 22"/>
+          <p:cNvSpPr/>
+          <p:nvPr/>
+        </p:nvSpPr>
+        <p:spPr>
+          <a:xfrm>
+            <a:off x="6263640" y="2761488"/>
+            <a:ext cx="2286000" cy="9144"/>
+          </a:xfrm>
+          <a:prstGeom prst="rect">
+            <a:avLst/>
+          </a:prstGeom>
+          <a:solidFill>
+            <a:srgbClr val="D9E0EA"/>
+          </a:solidFill>
+          <a:ln w="12700">
+            <a:solidFill>
+              <a:srgbClr val="D9E0EA"/>
+            </a:solidFill>
+            <a:prstDash val="solid"/>
+          </a:ln>
+        </p:spPr>
+      </p:sp>
+      <p:sp>
+        <p:nvSpPr>
+          <p:cNvPr id="25" name="Text 23"/>
+          <p:cNvSpPr txBox="1"/>
+          <p:nvPr/>
+        </p:nvSpPr>
+        <p:spPr>
+          <a:xfrm>
+            <a:off x="6263640" y="2834640"/>
+            <a:ext cx="2286000" cy="164592"/>
+          </a:xfrm>
+          <a:prstGeom prst="rect">
+            <a:avLst/>
+          </a:prstGeom>
+          <a:noFill/>
+          <a:ln/>
+        </p:spPr>
+        <p:txBody>
+          <a:bodyPr wrap="square" lIns="0" tIns="0" rIns="0" bIns="0" rtlCol="0" anchor="ctr"/>
+          <a:lstStyle/>
+          <a:p>
+            <a:pPr indent="0" marL="0">
+              <a:buNone/>
+            </a:pPr>
+            <a:r>
+              <a:rPr lang="en-US" sz="700" b="1" spc="100" kern="0" dirty="0">
+                <a:solidFill>
+                  <a:srgbClr val="B45309"/>
+                </a:solidFill>
+                <a:latin typeface="Calibri" pitchFamily="34" charset="0"/>
+                <a:ea typeface="Calibri" pitchFamily="34" charset="-122"/>
+                <a:cs typeface="Calibri" pitchFamily="34" charset="-120"/>
+              </a:rPr>
+              <a:t>PROPOSED USE CASE</a:t>
+            </a:r>
+            <a:endParaRPr lang="en-US" sz="700" dirty="0"/>
+          </a:p>
+        </p:txBody>
+      </p:sp>
+      <p:sp>
+        <p:nvSpPr>
+          <p:cNvPr id="26" name="Shape 24"/>
+          <p:cNvSpPr/>
+          <p:nvPr/>
+        </p:nvSpPr>
+        <p:spPr>
+          <a:xfrm>
+            <a:off x="6263640" y="1508760"/>
+            <a:ext cx="384048" cy="384048"/>
+          </a:xfrm>
+          <a:prstGeom prst="ellipse">
+            <a:avLst/>
+          </a:prstGeom>
+          <a:solidFill>
+            <a:srgbClr val="B45309"/>
+          </a:solidFill>
+          <a:ln w="12700">
+            <a:solidFill>
+              <a:srgbClr val="B45309"/>
+            </a:solidFill>
+            <a:prstDash val="solid"/>
+          </a:ln>
+        </p:spPr>
+      </p:sp>
+      <p:sp>
+        <p:nvSpPr>
+          <p:cNvPr id="27" name="Text 25"/>
+          <p:cNvSpPr txBox="1"/>
+          <p:nvPr/>
+        </p:nvSpPr>
+        <p:spPr>
+          <a:xfrm>
+            <a:off x="6263640" y="1508760"/>
+            <a:ext cx="384048" cy="384048"/>
+          </a:xfrm>
+          <a:prstGeom prst="rect">
+            <a:avLst/>
+          </a:prstGeom>
+          <a:noFill/>
+          <a:ln/>
+        </p:spPr>
+        <p:txBody>
+          <a:bodyPr wrap="square" lIns="0" tIns="0" rIns="0" bIns="0" rtlCol="0" anchor="ctr"/>
+          <a:lstStyle/>
+          <a:p>
+            <a:pPr algn="ctr" indent="0" marL="0">
+              <a:buNone/>
+            </a:pPr>
+            <a:r>
+              <a:rPr lang="en-US" sz="1300" b="1" dirty="0">
+                <a:solidFill>
+                  <a:srgbClr val="FFFFFF"/>
+                </a:solidFill>
+                <a:latin typeface="Calibri" pitchFamily="34" charset="0"/>
+                <a:ea typeface="Calibri" pitchFamily="34" charset="-122"/>
+                <a:cs typeface="Calibri" pitchFamily="34" charset="-120"/>
+              </a:rPr>
+              <a:t>3</a:t>
+            </a:r>
+            <a:endParaRPr lang="en-US" sz="1300" dirty="0"/>
+          </a:p>
+        </p:txBody>
+      </p:sp>
+      <p:sp>
+        <p:nvSpPr>
+          <p:cNvPr id="28" name="Text 26"/>
+          <p:cNvSpPr txBox="1"/>
+          <p:nvPr/>
+        </p:nvSpPr>
+        <p:spPr>
+          <a:xfrm>
+            <a:off x="6766560" y="1508760"/>
+            <a:ext cx="1828800" cy="384048"/>
+          </a:xfrm>
+          <a:prstGeom prst="rect">
+            <a:avLst/>
+          </a:prstGeom>
+          <a:noFill/>
+          <a:ln/>
+        </p:spPr>
+        <p:txBody>
+          <a:bodyPr wrap="square" lIns="0" tIns="0" rIns="0" bIns="0" rtlCol="0" anchor="ctr"/>
+          <a:lstStyle/>
+          <a:p>
+            <a:pPr indent="0" marL="0">
+              <a:buNone/>
+            </a:pPr>
+            <a:r>
+              <a:rPr lang="en-US" sz="1300" b="1" dirty="0">
+                <a:solidFill>
+                  <a:srgbClr val="1C2433"/>
+                </a:solidFill>
+                <a:latin typeface="Calibri" pitchFamily="34" charset="0"/>
+                <a:ea typeface="Calibri" pitchFamily="34" charset="-122"/>
+                <a:cs typeface="Calibri" pitchFamily="34" charset="-120"/>
+              </a:rPr>
+              <a:t>Customers' own APIs</a:t>
+            </a:r>
+            <a:endParaRPr lang="en-US" sz="1300" dirty="0"/>
+          </a:p>
+        </p:txBody>
+      </p:sp>
+      <p:sp>
+        <p:nvSpPr>
+          <p:cNvPr id="29" name="Text 27"/>
+          <p:cNvSpPr txBox="1"/>
+          <p:nvPr/>
+        </p:nvSpPr>
+        <p:spPr>
+          <a:xfrm>
+            <a:off x="6263640" y="2011680"/>
+            <a:ext cx="2286000" cy="713232"/>
+          </a:xfrm>
+          <a:prstGeom prst="rect">
+            <a:avLst/>
+          </a:prstGeom>
+          <a:noFill/>
+          <a:ln/>
+        </p:spPr>
+        <p:txBody>
+          <a:bodyPr wrap="square" lIns="0" tIns="0" rIns="0" bIns="0" rtlCol="0" anchor="ctr"/>
+          <a:lstStyle/>
+          <a:p>
+            <a:pPr indent="0" marL="0">
+              <a:buNone/>
+            </a:pPr>
+            <a:r>
+              <a:rPr lang="en-US" sz="850" dirty="0">
+                <a:solidFill>
+                  <a:srgbClr val="4A5568"/>
+                </a:solidFill>
+                <a:latin typeface="Calibri" pitchFamily="34" charset="0"/>
+                <a:ea typeface="Calibri" pitchFamily="34" charset="-122"/>
+                <a:cs typeface="Calibri" pitchFamily="34" charset="-120"/>
+              </a:rPr>
+              <a:t>A customer's in-house systems sit beside the group's products. The gateway becomes the customer's AI integration layer.</a:t>
+            </a:r>
+            <a:endParaRPr lang="en-US" sz="850" dirty="0"/>
+          </a:p>
+        </p:txBody>
+      </p:sp>
+      <p:sp>
+        <p:nvSpPr>
+          <p:cNvPr id="30" name="Text 28"/>
+          <p:cNvSpPr txBox="1"/>
+          <p:nvPr/>
+        </p:nvSpPr>
+        <p:spPr>
+          <a:xfrm>
+            <a:off x="6263640" y="3017520"/>
+            <a:ext cx="2286000" cy="566928"/>
+          </a:xfrm>
+          <a:prstGeom prst="rect">
+            <a:avLst/>
+          </a:prstGeom>
+          <a:noFill/>
+          <a:ln/>
+        </p:spPr>
+        <p:txBody>
+          <a:bodyPr wrap="square" lIns="0" tIns="0" rIns="0" bIns="0" rtlCol="0" anchor="ctr"/>
+          <a:lstStyle/>
+          <a:p>
+            <a:pPr indent="0" marL="0">
+              <a:buNone/>
+            </a:pPr>
+            <a:r>
+              <a:rPr lang="en-US" sz="850" i="1" dirty="0">
+                <a:solidFill>
+                  <a:srgbClr val="1C2433"/>
+                </a:solidFill>
+                <a:latin typeface="Calibri" pitchFamily="34" charset="0"/>
+                <a:ea typeface="Calibri" pitchFamily="34" charset="-122"/>
+                <a:cs typeface="Calibri" pitchFamily="34" charset="-120"/>
+              </a:rPr>
+              <a:t>“Compare our own order system with the settlements received this week and list what is unpaid.”</a:t>
+            </a:r>
+            <a:endParaRPr lang="en-US" sz="850" dirty="0"/>
+          </a:p>
+        </p:txBody>
+      </p:sp>
+      <p:sp>
+        <p:nvSpPr>
+          <p:cNvPr id="31" name="Shape 29"/>
+          <p:cNvSpPr/>
+          <p:nvPr/>
+        </p:nvSpPr>
+        <p:spPr>
+          <a:xfrm>
+            <a:off x="411480" y="3794760"/>
+            <a:ext cx="8321040" cy="868680"/>
+          </a:xfrm>
+          <a:prstGeom prst="roundRect">
+            <a:avLst>
+              <a:gd name="adj" fmla="val 6316"/>
             </a:avLst>
           </a:prstGeom>
           <a:solidFill>
@@ -8489,117 +9122,53 @@
       </p:sp>
       <p:sp>
         <p:nvSpPr>
-          <p:cNvPr id="13" name="Shape 11"/>
-          <p:cNvSpPr/>
-          <p:nvPr/>
-        </p:nvSpPr>
-        <p:spPr>
-          <a:xfrm>
-            <a:off x="3429000" y="1508760"/>
-            <a:ext cx="384048" cy="384048"/>
-          </a:xfrm>
-          <a:prstGeom prst="ellipse">
-            <a:avLst/>
-          </a:prstGeom>
-          <a:solidFill>
-            <a:srgbClr val="14213D"/>
-          </a:solidFill>
-          <a:ln w="12700">
-            <a:solidFill>
-              <a:srgbClr val="14213D"/>
-            </a:solidFill>
-            <a:prstDash val="solid"/>
-          </a:ln>
-        </p:spPr>
-      </p:sp>
-      <p:sp>
-        <p:nvSpPr>
-          <p:cNvPr id="14" name="Text 12"/>
-          <p:cNvSpPr txBox="1"/>
-          <p:nvPr/>
-        </p:nvSpPr>
-        <p:spPr>
-          <a:xfrm>
-            <a:off x="3429000" y="1508760"/>
-            <a:ext cx="384048" cy="384048"/>
-          </a:xfrm>
-          <a:prstGeom prst="rect">
-            <a:avLst/>
-          </a:prstGeom>
-          <a:noFill/>
-          <a:ln/>
-        </p:spPr>
-        <p:txBody>
-          <a:bodyPr wrap="square" lIns="0" tIns="0" rIns="0" bIns="0" rtlCol="0" anchor="ctr"/>
-          <a:lstStyle/>
-          <a:p>
-            <a:pPr algn="ctr" indent="0" marL="0">
-              <a:buNone/>
-            </a:pPr>
-            <a:r>
-              <a:rPr lang="en-US" sz="1300" b="1" dirty="0">
-                <a:solidFill>
-                  <a:srgbClr val="FFFFFF"/>
-                </a:solidFill>
-                <a:latin typeface="Calibri" pitchFamily="34" charset="0"/>
-                <a:ea typeface="Calibri" pitchFamily="34" charset="-122"/>
-                <a:cs typeface="Calibri" pitchFamily="34" charset="-120"/>
-              </a:rPr>
-              <a:t>2</a:t>
-            </a:r>
-            <a:endParaRPr lang="en-US" sz="1300" dirty="0"/>
-          </a:p>
-        </p:txBody>
-      </p:sp>
-      <p:sp>
-        <p:nvSpPr>
-          <p:cNvPr id="15" name="Text 13"/>
-          <p:cNvSpPr txBox="1"/>
-          <p:nvPr/>
-        </p:nvSpPr>
-        <p:spPr>
-          <a:xfrm>
-            <a:off x="3931920" y="1508760"/>
-            <a:ext cx="1828800" cy="384048"/>
-          </a:xfrm>
-          <a:prstGeom prst="rect">
-            <a:avLst/>
-          </a:prstGeom>
-          <a:noFill/>
-          <a:ln/>
-        </p:spPr>
-        <p:txBody>
-          <a:bodyPr wrap="square" lIns="0" tIns="0" rIns="0" bIns="0" rtlCol="0" anchor="ctr"/>
-          <a:lstStyle/>
-          <a:p>
-            <a:pPr indent="0" marL="0">
-              <a:buNone/>
-            </a:pPr>
-            <a:r>
-              <a:rPr lang="en-US" sz="1300" b="1" dirty="0">
-                <a:solidFill>
-                  <a:srgbClr val="1C2433"/>
-                </a:solidFill>
-                <a:latin typeface="Calibri" pitchFamily="34" charset="0"/>
-                <a:ea typeface="Calibri" pitchFamily="34" charset="-122"/>
-                <a:cs typeface="Calibri" pitchFamily="34" charset="-120"/>
-              </a:rPr>
-              <a:t>Partner SaaS</a:t>
-            </a:r>
-            <a:endParaRPr lang="en-US" sz="1300" dirty="0"/>
-          </a:p>
-        </p:txBody>
-      </p:sp>
-      <p:sp>
-        <p:nvSpPr>
-          <p:cNvPr id="16" name="Text 14"/>
-          <p:cNvSpPr txBox="1"/>
-          <p:nvPr/>
-        </p:nvSpPr>
-        <p:spPr>
-          <a:xfrm>
-            <a:off x="3429000" y="2011680"/>
-            <a:ext cx="2286000" cy="960120"/>
+          <p:cNvPr id="32" name="Text 30"/>
+          <p:cNvSpPr txBox="1"/>
+          <p:nvPr/>
+        </p:nvSpPr>
+        <p:spPr>
+          <a:xfrm>
+            <a:off x="594360" y="3867912"/>
+            <a:ext cx="2743200" cy="182880"/>
+          </a:xfrm>
+          <a:prstGeom prst="rect">
+            <a:avLst/>
+          </a:prstGeom>
+          <a:noFill/>
+          <a:ln/>
+        </p:spPr>
+        <p:txBody>
+          <a:bodyPr wrap="square" lIns="0" tIns="0" rIns="0" bIns="0" rtlCol="0" anchor="ctr"/>
+          <a:lstStyle/>
+          <a:p>
+            <a:pPr indent="0" marL="0">
+              <a:buNone/>
+            </a:pPr>
+            <a:r>
+              <a:rPr lang="en-US" sz="800" b="1" spc="100" kern="0" dirty="0">
+                <a:solidFill>
+                  <a:srgbClr val="0F766E"/>
+                </a:solidFill>
+                <a:latin typeface="Calibri" pitchFamily="34" charset="0"/>
+                <a:ea typeface="Calibri" pitchFamily="34" charset="-122"/>
+                <a:cs typeface="Calibri" pitchFamily="34" charset="-120"/>
+              </a:rPr>
+              <a:t>ECOSYSTEM CONDITION</a:t>
+            </a:r>
+            <a:endParaRPr lang="en-US" sz="800" dirty="0"/>
+          </a:p>
+        </p:txBody>
+      </p:sp>
+      <p:sp>
+        <p:nvSpPr>
+          <p:cNvPr id="33" name="Text 31"/>
+          <p:cNvSpPr txBox="1"/>
+          <p:nvPr/>
+        </p:nvSpPr>
+        <p:spPr>
+          <a:xfrm>
+            <a:off x="594360" y="4069080"/>
+            <a:ext cx="7955280" cy="548640"/>
           </a:xfrm>
           <a:prstGeom prst="rect">
             <a:avLst/>
@@ -8623,7 +9192,7 @@
                 <a:ea typeface="Calibri" pitchFamily="34" charset="-122"/>
                 <a:cs typeface="Calibri" pitchFamily="34" charset="-120"/>
               </a:rPr>
-              <a:t>ERP, HR, groupware, tax. Registered in the same registry, governed by the same policy, so a customer's whole workflow completes in one place.</a:t>
+              <a:t>The registry is open to third parties: a partner adds value by registering a product, a customer by registering its own systems. An ecosystem forms when others build on the control layer, not when Webcash connects everything itself. The group's asset is the control layer: identity, policy and audit that every connection inherits.</a:t>
             </a:r>
             <a:endParaRPr lang="en-US" sz="850" dirty="0"/>
           </a:p>
@@ -8631,384 +9200,7 @@
       </p:sp>
       <p:sp>
         <p:nvSpPr>
-          <p:cNvPr id="17" name="Text 15"/>
-          <p:cNvSpPr txBox="1"/>
-          <p:nvPr/>
-        </p:nvSpPr>
-        <p:spPr>
-          <a:xfrm>
-            <a:off x="3429000" y="3035808"/>
-            <a:ext cx="2286000" cy="228600"/>
-          </a:xfrm>
-          <a:prstGeom prst="rect">
-            <a:avLst/>
-          </a:prstGeom>
-          <a:noFill/>
-          <a:ln/>
-        </p:spPr>
-        <p:txBody>
-          <a:bodyPr wrap="square" lIns="0" tIns="0" rIns="0" bIns="0" rtlCol="0" anchor="ctr"/>
-          <a:lstStyle/>
-          <a:p>
-            <a:pPr indent="0" marL="0">
-              <a:buNone/>
-            </a:pPr>
-            <a:r>
-              <a:rPr lang="en-US" sz="800" b="1" spc="100" kern="0" dirty="0">
-                <a:solidFill>
-                  <a:srgbClr val="14213D"/>
-                </a:solidFill>
-                <a:latin typeface="Calibri" pitchFamily="34" charset="0"/>
-                <a:ea typeface="Calibri" pitchFamily="34" charset="-122"/>
-                <a:cs typeface="Calibri" pitchFamily="34" charset="-120"/>
-              </a:rPr>
-              <a:t>next</a:t>
-            </a:r>
-            <a:endParaRPr lang="en-US" sz="800" dirty="0"/>
-          </a:p>
-        </p:txBody>
-      </p:sp>
-      <p:sp>
-        <p:nvSpPr>
-          <p:cNvPr id="18" name="Shape 16"/>
-          <p:cNvSpPr/>
-          <p:nvPr/>
-        </p:nvSpPr>
-        <p:spPr>
-          <a:xfrm>
-            <a:off x="5925312" y="2212848"/>
-            <a:ext cx="128016" cy="219456"/>
-          </a:xfrm>
-          <a:prstGeom prst="rightArrow">
-            <a:avLst/>
-          </a:prstGeom>
-          <a:solidFill>
-            <a:srgbClr val="7A8593"/>
-          </a:solidFill>
-          <a:ln w="12700">
-            <a:solidFill>
-              <a:srgbClr val="7A8593"/>
-            </a:solidFill>
-            <a:prstDash val="solid"/>
-          </a:ln>
-        </p:spPr>
-      </p:sp>
-      <p:sp>
-        <p:nvSpPr>
-          <p:cNvPr id="19" name="Shape 17"/>
-          <p:cNvSpPr/>
-          <p:nvPr/>
-        </p:nvSpPr>
-        <p:spPr>
-          <a:xfrm>
-            <a:off x="6080760" y="1325880"/>
-            <a:ext cx="2651760" cy="2011680"/>
-          </a:xfrm>
-          <a:prstGeom prst="roundRect">
-            <a:avLst>
-              <a:gd name="adj" fmla="val 2727"/>
-            </a:avLst>
-          </a:prstGeom>
-          <a:solidFill>
-            <a:srgbClr val="F5F7FA"/>
-          </a:solidFill>
-          <a:ln w="9525">
-            <a:solidFill>
-              <a:srgbClr val="D9E0EA"/>
-            </a:solidFill>
-            <a:prstDash val="solid"/>
-          </a:ln>
-        </p:spPr>
-      </p:sp>
-      <p:sp>
-        <p:nvSpPr>
-          <p:cNvPr id="20" name="Shape 18"/>
-          <p:cNvSpPr/>
-          <p:nvPr/>
-        </p:nvSpPr>
-        <p:spPr>
-          <a:xfrm>
-            <a:off x="6263640" y="1508760"/>
-            <a:ext cx="384048" cy="384048"/>
-          </a:xfrm>
-          <a:prstGeom prst="ellipse">
-            <a:avLst/>
-          </a:prstGeom>
-          <a:solidFill>
-            <a:srgbClr val="B45309"/>
-          </a:solidFill>
-          <a:ln w="12700">
-            <a:solidFill>
-              <a:srgbClr val="B45309"/>
-            </a:solidFill>
-            <a:prstDash val="solid"/>
-          </a:ln>
-        </p:spPr>
-      </p:sp>
-      <p:sp>
-        <p:nvSpPr>
-          <p:cNvPr id="21" name="Text 19"/>
-          <p:cNvSpPr txBox="1"/>
-          <p:nvPr/>
-        </p:nvSpPr>
-        <p:spPr>
-          <a:xfrm>
-            <a:off x="6263640" y="1508760"/>
-            <a:ext cx="384048" cy="384048"/>
-          </a:xfrm>
-          <a:prstGeom prst="rect">
-            <a:avLst/>
-          </a:prstGeom>
-          <a:noFill/>
-          <a:ln/>
-        </p:spPr>
-        <p:txBody>
-          <a:bodyPr wrap="square" lIns="0" tIns="0" rIns="0" bIns="0" rtlCol="0" anchor="ctr"/>
-          <a:lstStyle/>
-          <a:p>
-            <a:pPr algn="ctr" indent="0" marL="0">
-              <a:buNone/>
-            </a:pPr>
-            <a:r>
-              <a:rPr lang="en-US" sz="1300" b="1" dirty="0">
-                <a:solidFill>
-                  <a:srgbClr val="FFFFFF"/>
-                </a:solidFill>
-                <a:latin typeface="Calibri" pitchFamily="34" charset="0"/>
-                <a:ea typeface="Calibri" pitchFamily="34" charset="-122"/>
-                <a:cs typeface="Calibri" pitchFamily="34" charset="-120"/>
-              </a:rPr>
-              <a:t>3</a:t>
-            </a:r>
-            <a:endParaRPr lang="en-US" sz="1300" dirty="0"/>
-          </a:p>
-        </p:txBody>
-      </p:sp>
-      <p:sp>
-        <p:nvSpPr>
-          <p:cNvPr id="22" name="Text 20"/>
-          <p:cNvSpPr txBox="1"/>
-          <p:nvPr/>
-        </p:nvSpPr>
-        <p:spPr>
-          <a:xfrm>
-            <a:off x="6766560" y="1508760"/>
-            <a:ext cx="1828800" cy="384048"/>
-          </a:xfrm>
-          <a:prstGeom prst="rect">
-            <a:avLst/>
-          </a:prstGeom>
-          <a:noFill/>
-          <a:ln/>
-        </p:spPr>
-        <p:txBody>
-          <a:bodyPr wrap="square" lIns="0" tIns="0" rIns="0" bIns="0" rtlCol="0" anchor="ctr"/>
-          <a:lstStyle/>
-          <a:p>
-            <a:pPr indent="0" marL="0">
-              <a:buNone/>
-            </a:pPr>
-            <a:r>
-              <a:rPr lang="en-US" sz="1300" b="1" dirty="0">
-                <a:solidFill>
-                  <a:srgbClr val="1C2433"/>
-                </a:solidFill>
-                <a:latin typeface="Calibri" pitchFamily="34" charset="0"/>
-                <a:ea typeface="Calibri" pitchFamily="34" charset="-122"/>
-                <a:cs typeface="Calibri" pitchFamily="34" charset="-120"/>
-              </a:rPr>
-              <a:t>Customers' own APIs</a:t>
-            </a:r>
-            <a:endParaRPr lang="en-US" sz="1300" dirty="0"/>
-          </a:p>
-        </p:txBody>
-      </p:sp>
-      <p:sp>
-        <p:nvSpPr>
-          <p:cNvPr id="23" name="Text 21"/>
-          <p:cNvSpPr txBox="1"/>
-          <p:nvPr/>
-        </p:nvSpPr>
-        <p:spPr>
-          <a:xfrm>
-            <a:off x="6263640" y="2011680"/>
-            <a:ext cx="2286000" cy="960120"/>
-          </a:xfrm>
-          <a:prstGeom prst="rect">
-            <a:avLst/>
-          </a:prstGeom>
-          <a:noFill/>
-          <a:ln/>
-        </p:spPr>
-        <p:txBody>
-          <a:bodyPr wrap="square" lIns="0" tIns="0" rIns="0" bIns="0" rtlCol="0" anchor="ctr"/>
-          <a:lstStyle/>
-          <a:p>
-            <a:pPr indent="0" marL="0">
-              <a:buNone/>
-            </a:pPr>
-            <a:r>
-              <a:rPr lang="en-US" sz="850" dirty="0">
-                <a:solidFill>
-                  <a:srgbClr val="4A5568"/>
-                </a:solidFill>
-                <a:latin typeface="Calibri" pitchFamily="34" charset="0"/>
-                <a:ea typeface="Calibri" pitchFamily="34" charset="-122"/>
-                <a:cs typeface="Calibri" pitchFamily="34" charset="-120"/>
-              </a:rPr>
-              <a:t>A customer's in-house systems sit beside the group's products. The gateway becomes the customer's AI integration layer.</a:t>
-            </a:r>
-            <a:endParaRPr lang="en-US" sz="850" dirty="0"/>
-          </a:p>
-        </p:txBody>
-      </p:sp>
-      <p:sp>
-        <p:nvSpPr>
-          <p:cNvPr id="24" name="Text 22"/>
-          <p:cNvSpPr txBox="1"/>
-          <p:nvPr/>
-        </p:nvSpPr>
-        <p:spPr>
-          <a:xfrm>
-            <a:off x="6263640" y="3035808"/>
-            <a:ext cx="2286000" cy="228600"/>
-          </a:xfrm>
-          <a:prstGeom prst="rect">
-            <a:avLst/>
-          </a:prstGeom>
-          <a:noFill/>
-          <a:ln/>
-        </p:spPr>
-        <p:txBody>
-          <a:bodyPr wrap="square" lIns="0" tIns="0" rIns="0" bIns="0" rtlCol="0" anchor="ctr"/>
-          <a:lstStyle/>
-          <a:p>
-            <a:pPr indent="0" marL="0">
-              <a:buNone/>
-            </a:pPr>
-            <a:r>
-              <a:rPr lang="en-US" sz="800" b="1" spc="100" kern="0" dirty="0">
-                <a:solidFill>
-                  <a:srgbClr val="B45309"/>
-                </a:solidFill>
-                <a:latin typeface="Calibri" pitchFamily="34" charset="0"/>
-                <a:ea typeface="Calibri" pitchFamily="34" charset="-122"/>
-                <a:cs typeface="Calibri" pitchFamily="34" charset="-120"/>
-              </a:rPr>
-              <a:t>later</a:t>
-            </a:r>
-            <a:endParaRPr lang="en-US" sz="800" dirty="0"/>
-          </a:p>
-        </p:txBody>
-      </p:sp>
-      <p:sp>
-        <p:nvSpPr>
-          <p:cNvPr id="25" name="Shape 23"/>
-          <p:cNvSpPr/>
-          <p:nvPr/>
-        </p:nvSpPr>
-        <p:spPr>
-          <a:xfrm>
-            <a:off x="411480" y="3520440"/>
-            <a:ext cx="8321040" cy="1097280"/>
-          </a:xfrm>
-          <a:prstGeom prst="roundRect">
-            <a:avLst>
-              <a:gd name="adj" fmla="val 5000"/>
-            </a:avLst>
-          </a:prstGeom>
-          <a:solidFill>
-            <a:srgbClr val="FFFFFF"/>
-          </a:solidFill>
-          <a:ln w="9525">
-            <a:solidFill>
-              <a:srgbClr val="D9E0EA"/>
-            </a:solidFill>
-            <a:prstDash val="solid"/>
-          </a:ln>
-        </p:spPr>
-      </p:sp>
-      <p:sp>
-        <p:nvSpPr>
-          <p:cNvPr id="26" name="Text 24"/>
-          <p:cNvSpPr txBox="1"/>
-          <p:nvPr/>
-        </p:nvSpPr>
-        <p:spPr>
-          <a:xfrm>
-            <a:off x="594360" y="3630168"/>
-            <a:ext cx="2743200" cy="182880"/>
-          </a:xfrm>
-          <a:prstGeom prst="rect">
-            <a:avLst/>
-          </a:prstGeom>
-          <a:noFill/>
-          <a:ln/>
-        </p:spPr>
-        <p:txBody>
-          <a:bodyPr wrap="square" lIns="0" tIns="0" rIns="0" bIns="0" rtlCol="0" anchor="ctr"/>
-          <a:lstStyle/>
-          <a:p>
-            <a:pPr indent="0" marL="0">
-              <a:buNone/>
-            </a:pPr>
-            <a:r>
-              <a:rPr lang="en-US" sz="800" b="1" spc="100" kern="0" dirty="0">
-                <a:solidFill>
-                  <a:srgbClr val="0F766E"/>
-                </a:solidFill>
-                <a:latin typeface="Calibri" pitchFamily="34" charset="0"/>
-                <a:ea typeface="Calibri" pitchFamily="34" charset="-122"/>
-                <a:cs typeface="Calibri" pitchFamily="34" charset="-120"/>
-              </a:rPr>
-              <a:t>ECOSYSTEM CONDITION</a:t>
-            </a:r>
-            <a:endParaRPr lang="en-US" sz="800" dirty="0"/>
-          </a:p>
-        </p:txBody>
-      </p:sp>
-      <p:sp>
-        <p:nvSpPr>
-          <p:cNvPr id="27" name="Text 25"/>
-          <p:cNvSpPr txBox="1"/>
-          <p:nvPr/>
-        </p:nvSpPr>
-        <p:spPr>
-          <a:xfrm>
-            <a:off x="594360" y="3840480"/>
-            <a:ext cx="7955280" cy="731520"/>
-          </a:xfrm>
-          <a:prstGeom prst="rect">
-            <a:avLst/>
-          </a:prstGeom>
-          <a:noFill/>
-          <a:ln/>
-        </p:spPr>
-        <p:txBody>
-          <a:bodyPr wrap="square" lIns="0" tIns="0" rIns="0" bIns="0" rtlCol="0" anchor="ctr"/>
-          <a:lstStyle/>
-          <a:p>
-            <a:pPr indent="0" marL="0">
-              <a:buNone/>
-            </a:pPr>
-            <a:r>
-              <a:rPr lang="en-US" sz="880" dirty="0">
-                <a:solidFill>
-                  <a:srgbClr val="4A5568"/>
-                </a:solidFill>
-                <a:latin typeface="Calibri" pitchFamily="34" charset="0"/>
-                <a:ea typeface="Calibri" pitchFamily="34" charset="-122"/>
-                <a:cs typeface="Calibri" pitchFamily="34" charset="-120"/>
-              </a:rPr>
-              <a:t>The registry is open to third parties: a partner adds value by registering a product, a customer by registering its own systems. An ecosystem forms when others build on the control layer, not when Webcash connects everything itself. The group's asset is the control layer: identity, policy and audit that every connection inherits.</a:t>
-            </a:r>
-            <a:endParaRPr lang="en-US" sz="880" dirty="0"/>
-          </a:p>
-        </p:txBody>
-      </p:sp>
-      <p:sp>
-        <p:nvSpPr>
-          <p:cNvPr id="28" name="Text 26"/>
+          <p:cNvPr id="34" name="Text 32"/>
           <p:cNvSpPr txBox="1"/>
           <p:nvPr/>
         </p:nvSpPr>
@@ -9047,7 +9239,7 @@
       </p:sp>
       <p:sp>
         <p:nvSpPr>
-          <p:cNvPr id="29" name="Text 27"/>
+          <p:cNvPr id="35" name="Text 33"/>
           <p:cNvSpPr txBox="1"/>
           <p:nvPr/>
         </p:nvSpPr>

</xml_diff>

<commit_message>
docs: rename architecture row to API to tools
Co-Authored-By: Claude Fable 5.1 <noreply@anthropic.com>
</commit_message>
<xml_diff>
--- a/docs/webcash-ai-gateway-concept-visual.pptx
+++ b/docs/webcash-ai-gateway-concept-visual.pptx
@@ -20641,7 +20641,7 @@
                 <a:ea typeface="Calibri" pitchFamily="34" charset="-122"/>
                 <a:cs typeface="Calibri" pitchFamily="34" charset="-120"/>
               </a:rPr>
-              <a:t>Tool generation</a:t>
+              <a:t>API to tools</a:t>
             </a:r>
             <a:endParaRPr lang="en-US" sz="850" dirty="0"/>
           </a:p>
@@ -20680,7 +20680,7 @@
                 <a:ea typeface="Calibri" pitchFamily="34" charset="-122"/>
                 <a:cs typeface="Calibri" pitchFamily="34" charset="-120"/>
               </a:rPr>
-              <a:t>OpenAPI spec → tools · existing MCP servers proxied · descriptions and risk editable by admins</a:t>
+              <a:t>One tool per API operation, generated from the OpenAPI spec · existing MCP servers passed through · descriptions and risk editable by admins</a:t>
             </a:r>
             <a:endParaRPr lang="en-US" sz="660" dirty="0"/>
           </a:p>

</xml_diff>

<commit_message>
docs: reframe proof slide as feasibility and proposed work as three tracks
Co-Authored-By: Claude Fable 5.1 <noreply@anthropic.com>
</commit_message>
<xml_diff>
--- a/docs/webcash-ai-gateway-concept-visual.pptx
+++ b/docs/webcash-ai-gateway-concept-visual.pptx
@@ -1135,7 +1135,7 @@
           <a:p>
             <a:r>
               <a:rPr lang="en-US" dirty="0"/>
-              <a:t>The only slide about the pilot. It exists to show the mechanism is real.</a:t>
+              <a:t>Feasibility, not a product tour. Say what is shown and, just as plainly, what is not: that gap is the proposal.</a:t>
             </a:r>
             <a:endParaRPr lang="en-US" dirty="0"/>
           </a:p>
@@ -2499,7 +2499,7 @@
                 <a:ea typeface="Calibri" pitchFamily="34" charset="-122"/>
                 <a:cs typeface="Calibri" pitchFamily="34" charset="-120"/>
               </a:rPr>
-              <a:t>Concept, architecture, control model, and the road from pilot to platform</a:t>
+              <a:t>Concept, architecture, control model, and the proposed work</a:t>
             </a:r>
             <a:endParaRPr lang="en-US" sz="1050" dirty="0"/>
           </a:p>
@@ -3779,7 +3779,7 @@
       </p:sp>
       <p:pic>
         <p:nvPicPr>
-          <p:cNvPr id="6" name="Image 0" descr="C:\Users\user\AppData\Local\Temp\deckcrops\gateway-wc-group-6.png">    </p:cNvPr>
+          <p:cNvPr id="6" name="Image 0" descr="C:\Users\user\AppData\Local\Temp\deckcrops\gateway-wc-group-7.png">    </p:cNvPr>
           <p:cNvPicPr>
             <a:picLocks noChangeAspect="1"/>
           </p:cNvPicPr>
@@ -6156,7 +6156,7 @@
       </p:sp>
       <p:pic>
         <p:nvPicPr>
-          <p:cNvPr id="6" name="Image 0" descr="C:\Users\user\AppData\Local\Temp\deckcrops\users-9.png">    </p:cNvPr>
+          <p:cNvPr id="6" name="Image 0" descr="C:\Users\user\AppData\Local\Temp\deckcrops\users-10.png">    </p:cNvPr>
           <p:cNvPicPr>
             <a:picLocks noChangeAspect="1"/>
           </p:cNvPicPr>
@@ -6214,7 +6214,7 @@
       </p:sp>
       <p:pic>
         <p:nvPicPr>
-          <p:cNvPr id="8" name="Image 1" descr="C:\Users\user\AppData\Local\Temp\deckcrops\audit-8.png">    </p:cNvPr>
+          <p:cNvPr id="8" name="Image 1" descr="C:\Users\user\AppData\Local\Temp\deckcrops\audit-9.png">    </p:cNvPr>
           <p:cNvPicPr>
             <a:picLocks noChangeAspect="1"/>
           </p:cNvPicPr>
@@ -9341,7 +9341,7 @@
                 <a:ea typeface="Calibri" pitchFamily="34" charset="-122"/>
                 <a:cs typeface="Calibri" pitchFamily="34" charset="-120"/>
               </a:rPr>
-              <a:t>EVIDENCE</a:t>
+              <a:t>FEASIBILITY</a:t>
             </a:r>
             <a:endParaRPr lang="en-US" sz="800" dirty="0"/>
           </a:p>
@@ -9380,7 +9380,7 @@
                 <a:ea typeface="Calibri" pitchFamily="34" charset="-122"/>
                 <a:cs typeface="Calibri" pitchFamily="34" charset="-120"/>
               </a:rPr>
-              <a:t>Proof point: the mechanism runs today</a:t>
+              <a:t>Feasibility: the core mechanism is already demonstrated</a:t>
             </a:r>
             <a:endParaRPr lang="en-US" sz="2400" dirty="0"/>
           </a:p>
@@ -9419,7 +9419,7 @@
                 <a:ea typeface="Calibri" pitchFamily="34" charset="-122"/>
                 <a:cs typeface="Calibri" pitchFamily="34" charset="-120"/>
               </a:rPr>
-              <a:t>A first pilot on the expense and collaboration package, built with the AI Convergence Lab and used from real assistants.</a:t>
+              <a:t>A working prototype, built with the AI Convergence Lab, shows the control layer end to end with real products and real assistants.</a:t>
             </a:r>
             <a:endParaRPr lang="en-US" sz="1100" dirty="0"/>
           </a:p>
@@ -9433,12 +9433,12 @@
         </p:nvSpPr>
         <p:spPr>
           <a:xfrm>
-            <a:off x="411480" y="1371600"/>
-            <a:ext cx="2377440" cy="713232"/>
+            <a:off x="411480" y="1325880"/>
+            <a:ext cx="2377440" cy="530352"/>
           </a:xfrm>
           <a:prstGeom prst="roundRect">
             <a:avLst>
-              <a:gd name="adj" fmla="val 7692"/>
+              <a:gd name="adj" fmla="val 10345"/>
             </a:avLst>
           </a:prstGeom>
           <a:solidFill>
@@ -9460,24 +9460,24 @@
         </p:nvSpPr>
         <p:spPr>
           <a:xfrm>
-            <a:off x="594360" y="1417320"/>
-            <a:ext cx="914400" cy="621792"/>
-          </a:xfrm>
-          <a:prstGeom prst="rect">
-            <a:avLst/>
-          </a:prstGeom>
-          <a:noFill/>
-          <a:ln/>
-        </p:spPr>
-        <p:txBody>
-          <a:bodyPr wrap="square" lIns="0" tIns="0" rIns="0" bIns="0" rtlCol="0" anchor="ctr"/>
-          <a:lstStyle/>
-          <a:p>
-            <a:pPr indent="0" marL="0">
-              <a:buNone/>
-            </a:pPr>
-            <a:r>
-              <a:rPr lang="en-US" sz="2600" b="1" dirty="0">
+            <a:off x="594360" y="1325880"/>
+            <a:ext cx="822960" cy="530352"/>
+          </a:xfrm>
+          <a:prstGeom prst="rect">
+            <a:avLst/>
+          </a:prstGeom>
+          <a:noFill/>
+          <a:ln/>
+        </p:spPr>
+        <p:txBody>
+          <a:bodyPr wrap="square" lIns="0" tIns="0" rIns="0" bIns="0" rtlCol="0" anchor="ctr"/>
+          <a:lstStyle/>
+          <a:p>
+            <a:pPr indent="0" marL="0">
+              <a:buNone/>
+            </a:pPr>
+            <a:r>
+              <a:rPr lang="en-US" sz="2200" b="1" dirty="0">
                 <a:solidFill>
                   <a:srgbClr val="0F766E"/>
                 </a:solidFill>
@@ -9487,7 +9487,7 @@
               </a:rPr>
               <a:t>4</a:t>
             </a:r>
-            <a:endParaRPr lang="en-US" sz="2600" dirty="0"/>
+            <a:endParaRPr lang="en-US" sz="2200" dirty="0"/>
           </a:p>
         </p:txBody>
       </p:sp>
@@ -9499,24 +9499,24 @@
         </p:nvSpPr>
         <p:spPr>
           <a:xfrm>
-            <a:off x="1508760" y="1417320"/>
-            <a:ext cx="1234440" cy="621792"/>
-          </a:xfrm>
-          <a:prstGeom prst="rect">
-            <a:avLst/>
-          </a:prstGeom>
-          <a:noFill/>
-          <a:ln/>
-        </p:spPr>
-        <p:txBody>
-          <a:bodyPr wrap="square" lIns="0" tIns="0" rIns="0" bIns="0" rtlCol="0" anchor="ctr"/>
-          <a:lstStyle/>
-          <a:p>
-            <a:pPr indent="0" marL="0">
-              <a:buNone/>
-            </a:pPr>
-            <a:r>
-              <a:rPr lang="en-US" sz="900" b="1" dirty="0">
+            <a:off x="1371600" y="1325880"/>
+            <a:ext cx="1371600" cy="530352"/>
+          </a:xfrm>
+          <a:prstGeom prst="rect">
+            <a:avLst/>
+          </a:prstGeom>
+          <a:noFill/>
+          <a:ln/>
+        </p:spPr>
+        <p:txBody>
+          <a:bodyPr wrap="square" lIns="0" tIns="0" rIns="0" bIns="0" rtlCol="0" anchor="ctr"/>
+          <a:lstStyle/>
+          <a:p>
+            <a:pPr indent="0" marL="0">
+              <a:buNone/>
+            </a:pPr>
+            <a:r>
+              <a:rPr lang="en-US" sz="850" b="1" dirty="0">
                 <a:solidFill>
                   <a:srgbClr val="1C2433"/>
                 </a:solidFill>
@@ -9526,7 +9526,7 @@
               </a:rPr>
               <a:t>products behind one address</a:t>
             </a:r>
-            <a:endParaRPr lang="en-US" sz="900" dirty="0"/>
+            <a:endParaRPr lang="en-US" sz="850" dirty="0"/>
           </a:p>
         </p:txBody>
       </p:sp>
@@ -9538,12 +9538,12 @@
         </p:nvSpPr>
         <p:spPr>
           <a:xfrm>
-            <a:off x="411480" y="2176272"/>
-            <a:ext cx="2377440" cy="713232"/>
+            <a:off x="411480" y="1929384"/>
+            <a:ext cx="2377440" cy="530352"/>
           </a:xfrm>
           <a:prstGeom prst="roundRect">
             <a:avLst>
-              <a:gd name="adj" fmla="val 7692"/>
+              <a:gd name="adj" fmla="val 10345"/>
             </a:avLst>
           </a:prstGeom>
           <a:solidFill>
@@ -9565,24 +9565,24 @@
         </p:nvSpPr>
         <p:spPr>
           <a:xfrm>
-            <a:off x="594360" y="2221992"/>
-            <a:ext cx="914400" cy="621792"/>
-          </a:xfrm>
-          <a:prstGeom prst="rect">
-            <a:avLst/>
-          </a:prstGeom>
-          <a:noFill/>
-          <a:ln/>
-        </p:spPr>
-        <p:txBody>
-          <a:bodyPr wrap="square" lIns="0" tIns="0" rIns="0" bIns="0" rtlCol="0" anchor="ctr"/>
-          <a:lstStyle/>
-          <a:p>
-            <a:pPr indent="0" marL="0">
-              <a:buNone/>
-            </a:pPr>
-            <a:r>
-              <a:rPr lang="en-US" sz="2600" b="1" dirty="0">
+            <a:off x="594360" y="1929384"/>
+            <a:ext cx="822960" cy="530352"/>
+          </a:xfrm>
+          <a:prstGeom prst="rect">
+            <a:avLst/>
+          </a:prstGeom>
+          <a:noFill/>
+          <a:ln/>
+        </p:spPr>
+        <p:txBody>
+          <a:bodyPr wrap="square" lIns="0" tIns="0" rIns="0" bIns="0" rtlCol="0" anchor="ctr"/>
+          <a:lstStyle/>
+          <a:p>
+            <a:pPr indent="0" marL="0">
+              <a:buNone/>
+            </a:pPr>
+            <a:r>
+              <a:rPr lang="en-US" sz="2200" b="1" dirty="0">
                 <a:solidFill>
                   <a:srgbClr val="0F766E"/>
                 </a:solidFill>
@@ -9592,7 +9592,7 @@
               </a:rPr>
               <a:t>72</a:t>
             </a:r>
-            <a:endParaRPr lang="en-US" sz="2600" dirty="0"/>
+            <a:endParaRPr lang="en-US" sz="2200" dirty="0"/>
           </a:p>
         </p:txBody>
       </p:sp>
@@ -9604,24 +9604,24 @@
         </p:nvSpPr>
         <p:spPr>
           <a:xfrm>
-            <a:off x="1508760" y="2221992"/>
-            <a:ext cx="1234440" cy="621792"/>
-          </a:xfrm>
-          <a:prstGeom prst="rect">
-            <a:avLst/>
-          </a:prstGeom>
-          <a:noFill/>
-          <a:ln/>
-        </p:spPr>
-        <p:txBody>
-          <a:bodyPr wrap="square" lIns="0" tIns="0" rIns="0" bIns="0" rtlCol="0" anchor="ctr"/>
-          <a:lstStyle/>
-          <a:p>
-            <a:pPr indent="0" marL="0">
-              <a:buNone/>
-            </a:pPr>
-            <a:r>
-              <a:rPr lang="en-US" sz="900" b="1" dirty="0">
+            <a:off x="1371600" y="1929384"/>
+            <a:ext cx="1371600" cy="530352"/>
+          </a:xfrm>
+          <a:prstGeom prst="rect">
+            <a:avLst/>
+          </a:prstGeom>
+          <a:noFill/>
+          <a:ln/>
+        </p:spPr>
+        <p:txBody>
+          <a:bodyPr wrap="square" lIns="0" tIns="0" rIns="0" bIns="0" rtlCol="0" anchor="ctr"/>
+          <a:lstStyle/>
+          <a:p>
+            <a:pPr indent="0" marL="0">
+              <a:buNone/>
+            </a:pPr>
+            <a:r>
+              <a:rPr lang="en-US" sz="850" b="1" dirty="0">
                 <a:solidFill>
                   <a:srgbClr val="1C2433"/>
                 </a:solidFill>
@@ -9629,9 +9629,9 @@
                 <a:ea typeface="Calibri" pitchFamily="34" charset="-122"/>
                 <a:cs typeface="Calibri" pitchFamily="34" charset="-120"/>
               </a:rPr>
-              <a:t>tools generated or proxied</a:t>
-            </a:r>
-            <a:endParaRPr lang="en-US" sz="900" dirty="0"/>
+              <a:t>tools, with no product code changed</a:t>
+            </a:r>
+            <a:endParaRPr lang="en-US" sz="850" dirty="0"/>
           </a:p>
         </p:txBody>
       </p:sp>
@@ -9643,12 +9643,12 @@
         </p:nvSpPr>
         <p:spPr>
           <a:xfrm>
-            <a:off x="411480" y="2980944"/>
-            <a:ext cx="2377440" cy="713232"/>
+            <a:off x="411480" y="2532888"/>
+            <a:ext cx="2377440" cy="530352"/>
           </a:xfrm>
           <a:prstGeom prst="roundRect">
             <a:avLst>
-              <a:gd name="adj" fmla="val 7692"/>
+              <a:gd name="adj" fmla="val 10345"/>
             </a:avLst>
           </a:prstGeom>
           <a:solidFill>
@@ -9670,24 +9670,24 @@
         </p:nvSpPr>
         <p:spPr>
           <a:xfrm>
-            <a:off x="594360" y="3026664"/>
-            <a:ext cx="914400" cy="621792"/>
-          </a:xfrm>
-          <a:prstGeom prst="rect">
-            <a:avLst/>
-          </a:prstGeom>
-          <a:noFill/>
-          <a:ln/>
-        </p:spPr>
-        <p:txBody>
-          <a:bodyPr wrap="square" lIns="0" tIns="0" rIns="0" bIns="0" rtlCol="0" anchor="ctr"/>
-          <a:lstStyle/>
-          <a:p>
-            <a:pPr indent="0" marL="0">
-              <a:buNone/>
-            </a:pPr>
-            <a:r>
-              <a:rPr lang="en-US" sz="2600" b="1" dirty="0">
+            <a:off x="594360" y="2532888"/>
+            <a:ext cx="822960" cy="530352"/>
+          </a:xfrm>
+          <a:prstGeom prst="rect">
+            <a:avLst/>
+          </a:prstGeom>
+          <a:noFill/>
+          <a:ln/>
+        </p:spPr>
+        <p:txBody>
+          <a:bodyPr wrap="square" lIns="0" tIns="0" rIns="0" bIns="0" rtlCol="0" anchor="ctr"/>
+          <a:lstStyle/>
+          <a:p>
+            <a:pPr indent="0" marL="0">
+              <a:buNone/>
+            </a:pPr>
+            <a:r>
+              <a:rPr lang="en-US" sz="2200" b="1" dirty="0">
                 <a:solidFill>
                   <a:srgbClr val="0F766E"/>
                 </a:solidFill>
@@ -9697,7 +9697,7 @@
               </a:rPr>
               <a:t>1</a:t>
             </a:r>
-            <a:endParaRPr lang="en-US" sz="2600" dirty="0"/>
+            <a:endParaRPr lang="en-US" sz="2200" dirty="0"/>
           </a:p>
         </p:txBody>
       </p:sp>
@@ -9709,24 +9709,24 @@
         </p:nvSpPr>
         <p:spPr>
           <a:xfrm>
-            <a:off x="1508760" y="3026664"/>
-            <a:ext cx="1234440" cy="621792"/>
-          </a:xfrm>
-          <a:prstGeom prst="rect">
-            <a:avLst/>
-          </a:prstGeom>
-          <a:noFill/>
-          <a:ln/>
-        </p:spPr>
-        <p:txBody>
-          <a:bodyPr wrap="square" lIns="0" tIns="0" rIns="0" bIns="0" rtlCol="0" anchor="ctr"/>
-          <a:lstStyle/>
-          <a:p>
-            <a:pPr indent="0" marL="0">
-              <a:buNone/>
-            </a:pPr>
-            <a:r>
-              <a:rPr lang="en-US" sz="900" b="1" dirty="0">
+            <a:off x="1371600" y="2532888"/>
+            <a:ext cx="1371600" cy="530352"/>
+          </a:xfrm>
+          <a:prstGeom prst="rect">
+            <a:avLst/>
+          </a:prstGeom>
+          <a:noFill/>
+          <a:ln/>
+        </p:spPr>
+        <p:txBody>
+          <a:bodyPr wrap="square" lIns="0" tIns="0" rIns="0" bIns="0" rtlCol="0" anchor="ctr"/>
+          <a:lstStyle/>
+          <a:p>
+            <a:pPr indent="0" marL="0">
+              <a:buNone/>
+            </a:pPr>
+            <a:r>
+              <a:rPr lang="en-US" sz="850" b="1" dirty="0">
                 <a:solidFill>
                   <a:srgbClr val="1C2433"/>
                 </a:solidFill>
@@ -9736,7 +9736,7 @@
               </a:rPr>
               <a:t>sign-in for the customer</a:t>
             </a:r>
-            <a:endParaRPr lang="en-US" sz="900" dirty="0"/>
+            <a:endParaRPr lang="en-US" sz="850" dirty="0"/>
           </a:p>
         </p:txBody>
       </p:sp>
@@ -9748,12 +9748,12 @@
         </p:nvSpPr>
         <p:spPr>
           <a:xfrm>
-            <a:off x="411480" y="3785616"/>
-            <a:ext cx="2377440" cy="713232"/>
+            <a:off x="411480" y="3136392"/>
+            <a:ext cx="2377440" cy="530352"/>
           </a:xfrm>
           <a:prstGeom prst="roundRect">
             <a:avLst>
-              <a:gd name="adj" fmla="val 7692"/>
+              <a:gd name="adj" fmla="val 10345"/>
             </a:avLst>
           </a:prstGeom>
           <a:solidFill>
@@ -9775,24 +9775,24 @@
         </p:nvSpPr>
         <p:spPr>
           <a:xfrm>
-            <a:off x="594360" y="3831336"/>
-            <a:ext cx="914400" cy="621792"/>
-          </a:xfrm>
-          <a:prstGeom prst="rect">
-            <a:avLst/>
-          </a:prstGeom>
-          <a:noFill/>
-          <a:ln/>
-        </p:spPr>
-        <p:txBody>
-          <a:bodyPr wrap="square" lIns="0" tIns="0" rIns="0" bIns="0" rtlCol="0" anchor="ctr"/>
-          <a:lstStyle/>
-          <a:p>
-            <a:pPr indent="0" marL="0">
-              <a:buNone/>
-            </a:pPr>
-            <a:r>
-              <a:rPr lang="en-US" sz="2600" b="1" dirty="0">
+            <a:off x="594360" y="3136392"/>
+            <a:ext cx="822960" cy="530352"/>
+          </a:xfrm>
+          <a:prstGeom prst="rect">
+            <a:avLst/>
+          </a:prstGeom>
+          <a:noFill/>
+          <a:ln/>
+        </p:spPr>
+        <p:txBody>
+          <a:bodyPr wrap="square" lIns="0" tIns="0" rIns="0" bIns="0" rtlCol="0" anchor="ctr"/>
+          <a:lstStyle/>
+          <a:p>
+            <a:pPr indent="0" marL="0">
+              <a:buNone/>
+            </a:pPr>
+            <a:r>
+              <a:rPr lang="en-US" sz="2200" b="1" dirty="0">
                 <a:solidFill>
                   <a:srgbClr val="0F766E"/>
                 </a:solidFill>
@@ -9800,9 +9800,9 @@
                 <a:ea typeface="Calibri" pitchFamily="34" charset="-122"/>
                 <a:cs typeface="Calibri" pitchFamily="34" charset="-120"/>
               </a:rPr>
-              <a:t>99</a:t>
-            </a:r>
-            <a:endParaRPr lang="en-US" sz="2600" dirty="0"/>
+              <a:t>0</a:t>
+            </a:r>
+            <a:endParaRPr lang="en-US" sz="2200" dirty="0"/>
           </a:p>
         </p:txBody>
       </p:sp>
@@ -9814,24 +9814,24 @@
         </p:nvSpPr>
         <p:spPr>
           <a:xfrm>
-            <a:off x="1508760" y="3831336"/>
-            <a:ext cx="1234440" cy="621792"/>
-          </a:xfrm>
-          <a:prstGeom prst="rect">
-            <a:avLst/>
-          </a:prstGeom>
-          <a:noFill/>
-          <a:ln/>
-        </p:spPr>
-        <p:txBody>
-          <a:bodyPr wrap="square" lIns="0" tIns="0" rIns="0" bIns="0" rtlCol="0" anchor="ctr"/>
-          <a:lstStyle/>
-          <a:p>
-            <a:pPr indent="0" marL="0">
-              <a:buNone/>
-            </a:pPr>
-            <a:r>
-              <a:rPr lang="en-US" sz="900" b="1" dirty="0">
+            <a:off x="1371600" y="3136392"/>
+            <a:ext cx="1371600" cy="530352"/>
+          </a:xfrm>
+          <a:prstGeom prst="rect">
+            <a:avLst/>
+          </a:prstGeom>
+          <a:noFill/>
+          <a:ln/>
+        </p:spPr>
+        <p:txBody>
+          <a:bodyPr wrap="square" lIns="0" tIns="0" rIns="0" bIns="0" rtlCol="0" anchor="ctr"/>
+          <a:lstStyle/>
+          <a:p>
+            <a:pPr indent="0" marL="0">
+              <a:buNone/>
+            </a:pPr>
+            <a:r>
+              <a:rPr lang="en-US" sz="850" b="1" dirty="0">
                 <a:solidFill>
                   <a:srgbClr val="1C2433"/>
                 </a:solidFill>
@@ -9839,9 +9839,9 @@
                 <a:ea typeface="Calibri" pitchFamily="34" charset="-122"/>
                 <a:cs typeface="Calibri" pitchFamily="34" charset="-120"/>
               </a:rPr>
-              <a:t>automated tests</a:t>
-            </a:r>
-            <a:endParaRPr lang="en-US" sz="900" dirty="0"/>
+              <a:t>changes to the products</a:t>
+            </a:r>
+            <a:endParaRPr lang="en-US" sz="850" dirty="0"/>
           </a:p>
         </p:txBody>
       </p:sp>
@@ -9853,12 +9853,12 @@
         </p:nvSpPr>
         <p:spPr>
           <a:xfrm>
-            <a:off x="3853599" y="1316736"/>
-            <a:ext cx="4042842" cy="2761488"/>
+            <a:off x="2962656" y="1610513"/>
+            <a:ext cx="5824728" cy="1625294"/>
           </a:xfrm>
           <a:prstGeom prst="roundRect">
             <a:avLst>
-              <a:gd name="adj" fmla="val 1987"/>
+              <a:gd name="adj" fmla="val 3376"/>
             </a:avLst>
           </a:prstGeom>
           <a:solidFill>
@@ -9881,7 +9881,7 @@
       </p:sp>
       <p:pic>
         <p:nvPicPr>
-          <p:cNvPr id="18" name="Image 0" descr="C:\Users\user\AppData\Local\Temp\deckcrops\signins-7.png">    </p:cNvPr>
+          <p:cNvPr id="18" name="Image 0" descr="C:\Users\user\AppData\Local\Temp\deckcrops\overview-3.png">    </p:cNvPr>
           <p:cNvPicPr>
             <a:picLocks noChangeAspect="1"/>
           </p:cNvPicPr>
@@ -9895,8 +9895,8 @@
         </p:blipFill>
         <p:spPr>
           <a:xfrm>
-            <a:off x="3908463" y="1371600"/>
-            <a:ext cx="3933114" cy="2651760"/>
+            <a:off x="3017520" y="1665377"/>
+            <a:ext cx="5715000" cy="1515566"/>
           </a:xfrm>
           <a:prstGeom prst="rect">
             <a:avLst/>
@@ -9911,8 +9911,8 @@
         </p:nvSpPr>
         <p:spPr>
           <a:xfrm>
-            <a:off x="3908463" y="4078224"/>
-            <a:ext cx="3933114" cy="201168"/>
+            <a:off x="3017520" y="3235807"/>
+            <a:ext cx="5715000" cy="182880"/>
           </a:xfrm>
           <a:prstGeom prst="rect">
             <a:avLst/>
@@ -9928,6 +9928,111 @@
               <a:buNone/>
             </a:pPr>
             <a:r>
+              <a:rPr lang="en-US" sz="750" i="1" dirty="0">
+                <a:solidFill>
+                  <a:srgbClr val="7A8593"/>
+                </a:solidFill>
+                <a:latin typeface="Calibri" pitchFamily="34" charset="0"/>
+                <a:ea typeface="Calibri" pitchFamily="34" charset="-122"/>
+                <a:cs typeface="Calibri" pitchFamily="34" charset="-120"/>
+              </a:rPr>
+              <a:t>Prototype portal: assistant calls per day through the gateway, allowed, denied and failed</a:t>
+            </a:r>
+            <a:endParaRPr lang="en-US" sz="750" dirty="0"/>
+          </a:p>
+        </p:txBody>
+      </p:sp>
+      <p:sp>
+        <p:nvSpPr>
+          <p:cNvPr id="20" name="Shape 17"/>
+          <p:cNvSpPr/>
+          <p:nvPr/>
+        </p:nvSpPr>
+        <p:spPr>
+          <a:xfrm>
+            <a:off x="411480" y="3840480"/>
+            <a:ext cx="4069080" cy="841248"/>
+          </a:xfrm>
+          <a:prstGeom prst="roundRect">
+            <a:avLst>
+              <a:gd name="adj" fmla="val 6522"/>
+            </a:avLst>
+          </a:prstGeom>
+          <a:solidFill>
+            <a:srgbClr val="E6F4F1"/>
+          </a:solidFill>
+          <a:ln w="9525">
+            <a:solidFill>
+              <a:srgbClr val="0F766E"/>
+            </a:solidFill>
+            <a:prstDash val="solid"/>
+          </a:ln>
+        </p:spPr>
+      </p:sp>
+      <p:sp>
+        <p:nvSpPr>
+          <p:cNvPr id="21" name="Text 18"/>
+          <p:cNvSpPr txBox="1"/>
+          <p:nvPr/>
+        </p:nvSpPr>
+        <p:spPr>
+          <a:xfrm>
+            <a:off x="566928" y="3904488"/>
+            <a:ext cx="3657600" cy="182880"/>
+          </a:xfrm>
+          <a:prstGeom prst="rect">
+            <a:avLst/>
+          </a:prstGeom>
+          <a:noFill/>
+          <a:ln/>
+        </p:spPr>
+        <p:txBody>
+          <a:bodyPr wrap="square" lIns="0" tIns="0" rIns="0" bIns="0" rtlCol="0" anchor="ctr"/>
+          <a:lstStyle/>
+          <a:p>
+            <a:pPr indent="0" marL="0">
+              <a:buNone/>
+            </a:pPr>
+            <a:r>
+              <a:rPr lang="en-US" sz="800" b="1" spc="100" kern="0" dirty="0">
+                <a:solidFill>
+                  <a:srgbClr val="0F766E"/>
+                </a:solidFill>
+                <a:latin typeface="Calibri" pitchFamily="34" charset="0"/>
+                <a:ea typeface="Calibri" pitchFamily="34" charset="-122"/>
+                <a:cs typeface="Calibri" pitchFamily="34" charset="-120"/>
+              </a:rPr>
+              <a:t>WHAT THE PROTOTYPE SHOWS</a:t>
+            </a:r>
+            <a:endParaRPr lang="en-US" sz="800" dirty="0"/>
+          </a:p>
+        </p:txBody>
+      </p:sp>
+      <p:sp>
+        <p:nvSpPr>
+          <p:cNvPr id="22" name="Text 19"/>
+          <p:cNvSpPr txBox="1"/>
+          <p:nvPr/>
+        </p:nvSpPr>
+        <p:spPr>
+          <a:xfrm>
+            <a:off x="566928" y="4096512"/>
+            <a:ext cx="3749040" cy="548640"/>
+          </a:xfrm>
+          <a:prstGeom prst="rect">
+            <a:avLst/>
+          </a:prstGeom>
+          <a:noFill/>
+          <a:ln/>
+        </p:spPr>
+        <p:txBody>
+          <a:bodyPr wrap="square" lIns="0" tIns="0" rIns="0" bIns="0" rtlCol="0" anchor="ctr"/>
+          <a:lstStyle/>
+          <a:p>
+            <a:pPr indent="0" marL="0">
+              <a:buNone/>
+            </a:pPr>
+            <a:r>
               <a:rPr lang="en-US" sz="800" dirty="0">
                 <a:solidFill>
                   <a:srgbClr val="4A5568"/>
@@ -9936,7 +10041,7 @@
                 <a:ea typeface="Calibri" pitchFamily="34" charset="-122"/>
                 <a:cs typeface="Calibri" pitchFamily="34" charset="-120"/>
               </a:rPr>
-              <a:t>Sign-in log of the live gateway: every step from discovery to token, and every refused call</a:t>
+              <a:t>One chat across FLOW, COOCON and Bizplay with three kinds of product authentication. Writes refused until enabled, cross-organization lookups refused at the gateway, every step recorded.</a:t>
             </a:r>
             <a:endParaRPr lang="en-US" sz="800" dirty="0"/>
           </a:p>
@@ -9944,38 +10049,65 @@
       </p:sp>
       <p:sp>
         <p:nvSpPr>
-          <p:cNvPr id="20" name="Text 17"/>
-          <p:cNvSpPr txBox="1"/>
-          <p:nvPr/>
-        </p:nvSpPr>
-        <p:spPr>
-          <a:xfrm>
-            <a:off x="411480" y="4480560"/>
-            <a:ext cx="8321040" cy="274320"/>
-          </a:xfrm>
-          <a:prstGeom prst="rect">
-            <a:avLst/>
-          </a:prstGeom>
-          <a:noFill/>
-          <a:ln/>
-        </p:spPr>
-        <p:txBody>
-          <a:bodyPr wrap="square" lIns="0" tIns="0" rIns="0" bIns="0" rtlCol="0" anchor="ctr"/>
-          <a:lstStyle/>
-          <a:p>
-            <a:pPr indent="0" marL="0">
-              <a:buNone/>
-            </a:pPr>
-            <a:r>
-              <a:rPr lang="en-US" sz="800" i="1" dirty="0">
-                <a:solidFill>
-                  <a:srgbClr val="7A8593"/>
-                </a:solidFill>
-                <a:latin typeface="Calibri" pitchFamily="34" charset="0"/>
-                <a:ea typeface="Calibri" pitchFamily="34" charset="-122"/>
-                <a:cs typeface="Calibri" pitchFamily="34" charset="-120"/>
-              </a:rPr>
-              <a:t>Shown end to end in one chat from claude.ai: project status from FLOW, spending from COOCON, trips and receipts from Bizplay, compliance rules on card records, one dashboard at the end.</a:t>
+          <p:cNvPr id="23" name="Shape 20"/>
+          <p:cNvSpPr/>
+          <p:nvPr/>
+        </p:nvSpPr>
+        <p:spPr>
+          <a:xfrm>
+            <a:off x="4663440" y="3840480"/>
+            <a:ext cx="4069080" cy="841248"/>
+          </a:xfrm>
+          <a:prstGeom prst="roundRect">
+            <a:avLst>
+              <a:gd name="adj" fmla="val 6522"/>
+            </a:avLst>
+          </a:prstGeom>
+          <a:solidFill>
+            <a:srgbClr val="F5F7FA"/>
+          </a:solidFill>
+          <a:ln w="9525">
+            <a:solidFill>
+              <a:srgbClr val="D9E0EA"/>
+            </a:solidFill>
+            <a:prstDash val="solid"/>
+          </a:ln>
+        </p:spPr>
+      </p:sp>
+      <p:sp>
+        <p:nvSpPr>
+          <p:cNvPr id="24" name="Text 21"/>
+          <p:cNvSpPr txBox="1"/>
+          <p:nvPr/>
+        </p:nvSpPr>
+        <p:spPr>
+          <a:xfrm>
+            <a:off x="4818888" y="3904488"/>
+            <a:ext cx="3657600" cy="182880"/>
+          </a:xfrm>
+          <a:prstGeom prst="rect">
+            <a:avLst/>
+          </a:prstGeom>
+          <a:noFill/>
+          <a:ln/>
+        </p:spPr>
+        <p:txBody>
+          <a:bodyPr wrap="square" lIns="0" tIns="0" rIns="0" bIns="0" rtlCol="0" anchor="ctr"/>
+          <a:lstStyle/>
+          <a:p>
+            <a:pPr indent="0" marL="0">
+              <a:buNone/>
+            </a:pPr>
+            <a:r>
+              <a:rPr lang="en-US" sz="800" b="1" spc="100" kern="0" dirty="0">
+                <a:solidFill>
+                  <a:srgbClr val="B45309"/>
+                </a:solidFill>
+                <a:latin typeface="Calibri" pitchFamily="34" charset="0"/>
+                <a:ea typeface="Calibri" pitchFamily="34" charset="-122"/>
+                <a:cs typeface="Calibri" pitchFamily="34" charset="-120"/>
+              </a:rPr>
+              <a:t>WHAT IT DOES NOT YET SHOW</a:t>
             </a:r>
             <a:endParaRPr lang="en-US" sz="800" dirty="0"/>
           </a:p>
@@ -9983,7 +10115,46 @@
       </p:sp>
       <p:sp>
         <p:nvSpPr>
-          <p:cNvPr id="21" name="Text 18"/>
+          <p:cNvPr id="25" name="Text 22"/>
+          <p:cNvSpPr txBox="1"/>
+          <p:nvPr/>
+        </p:nvSpPr>
+        <p:spPr>
+          <a:xfrm>
+            <a:off x="4818888" y="4096512"/>
+            <a:ext cx="3749040" cy="548640"/>
+          </a:xfrm>
+          <a:prstGeom prst="rect">
+            <a:avLst/>
+          </a:prstGeom>
+          <a:noFill/>
+          <a:ln/>
+        </p:spPr>
+        <p:txBody>
+          <a:bodyPr wrap="square" lIns="0" tIns="0" rIns="0" bIns="0" rtlCol="0" anchor="ctr"/>
+          <a:lstStyle/>
+          <a:p>
+            <a:pPr indent="0" marL="0">
+              <a:buNone/>
+            </a:pPr>
+            <a:r>
+              <a:rPr lang="en-US" sz="800" dirty="0">
+                <a:solidFill>
+                  <a:srgbClr val="4A5568"/>
+                </a:solidFill>
+                <a:latin typeface="Calibri" pitchFamily="34" charset="0"/>
+                <a:ea typeface="Calibri" pitchFamily="34" charset="-122"/>
+                <a:cs typeface="Calibri" pitchFamily="34" charset="-120"/>
+              </a:rPr>
+              <a:t>Group single sign-on, approval-line integration for payments, operation at production scale, and results with real customer departments. These are the proposed work on the next slide.</a:t>
+            </a:r>
+            <a:endParaRPr lang="en-US" sz="800" dirty="0"/>
+          </a:p>
+        </p:txBody>
+      </p:sp>
+      <p:sp>
+        <p:nvSpPr>
+          <p:cNvPr id="26" name="Text 23"/>
           <p:cNvSpPr txBox="1"/>
           <p:nvPr/>
         </p:nvSpPr>
@@ -10022,7 +10193,7 @@
       </p:sp>
       <p:sp>
         <p:nvSpPr>
-          <p:cNvPr id="22" name="Text 19"/>
+          <p:cNvPr id="27" name="Text 24"/>
           <p:cNvSpPr txBox="1"/>
           <p:nvPr/>
         </p:nvSpPr>
@@ -10163,7 +10334,7 @@
                 <a:ea typeface="Calibri" pitchFamily="34" charset="-122"/>
                 <a:cs typeface="Calibri" pitchFamily="34" charset="-120"/>
               </a:rPr>
-              <a:t>From pilot to group platform</a:t>
+              <a:t>Proposed work: three tracks</a:t>
             </a:r>
             <a:endParaRPr lang="en-US" sz="2400" dirty="0"/>
           </a:p>
@@ -10202,7 +10373,7 @@
                 <a:ea typeface="Calibri" pitchFamily="34" charset="-122"/>
                 <a:cs typeface="Calibri" pitchFamily="34" charset="-120"/>
               </a:rPr>
-              <a:t>Three tracks over the next phase, each with something measurable at the end.</a:t>
+              <a:t>Platform, packages and research run in parallel, each with something measurable at the end.</a:t>
             </a:r>
             <a:endParaRPr lang="en-US" sz="1100" dirty="0"/>
           </a:p>
@@ -11534,7 +11705,7 @@
                 <a:ea typeface="Calibri" pitchFamily="34" charset="-122"/>
                 <a:cs typeface="Calibri" pitchFamily="34" charset="-120"/>
               </a:rPr>
-              <a:t>Pilot portal: mcp-portal.aiconvergencelab.com   ·   Code: github.com/Chansokheang/MCP_Server_Portal</a:t>
+              <a:t>Prototype: mcp-portal.aiconvergencelab.com   ·   Code: github.com/Chansokheang/MCP_Server_Portal</a:t>
             </a:r>
             <a:endParaRPr lang="en-US" sz="900" dirty="0"/>
           </a:p>
@@ -14555,7 +14726,7 @@
       </p:sp>
       <p:pic>
         <p:nvPicPr>
-          <p:cNvPr id="6" name="Image 0" descr="C:\Users\user\AppData\Local\Temp\deckcrops\authorize-3.png">    </p:cNvPr>
+          <p:cNvPr id="6" name="Image 0" descr="C:\Users\user\AppData\Local\Temp\deckcrops\authorize-4.png">    </p:cNvPr>
           <p:cNvPicPr>
             <a:picLocks noChangeAspect="1"/>
           </p:cNvPicPr>
@@ -16402,7 +16573,7 @@
       </p:sp>
       <p:pic>
         <p:nvPicPr>
-          <p:cNvPr id="6" name="Image 0" descr="C:\Users\user\AppData\Local\Temp\deckcrops\register-dialog-4.png">    </p:cNvPr>
+          <p:cNvPr id="6" name="Image 0" descr="C:\Users\user\AppData\Local\Temp\deckcrops\register-dialog-5.png">    </p:cNvPr>
           <p:cNvPicPr>
             <a:picLocks noChangeAspect="1"/>
           </p:cNvPicPr>
@@ -17294,7 +17465,7 @@
       </p:sp>
       <p:pic>
         <p:nvPicPr>
-          <p:cNvPr id="6" name="Image 0" descr="C:\Users\user\AppData\Local\Temp\deckcrops\provider-coocon-5.png">    </p:cNvPr>
+          <p:cNvPr id="6" name="Image 0" descr="C:\Users\user\AppData\Local\Temp\deckcrops\provider-coocon-6.png">    </p:cNvPr>
           <p:cNvPicPr>
             <a:picLocks noChangeAspect="1"/>
           </p:cNvPicPr>

</xml_diff>

<commit_message>
docs: feasibility slide argues the approach, prototype reduced to one line
Co-Authored-By: Claude Fable 5.1 <noreply@anthropic.com>
</commit_message>
<xml_diff>
--- a/docs/webcash-ai-gateway-concept-visual.pptx
+++ b/docs/webcash-ai-gateway-concept-visual.pptx
@@ -1135,7 +1135,7 @@
           <a:p>
             <a:r>
               <a:rPr lang="en-US" dirty="0"/>
-              <a:t>Feasibility, not a product tour. Say what is shown and, just as plainly, what is not: that gap is the proposal.</a:t>
+              <a:t>Feasibility of the proposal, not a tour of the prototype. The prototype is mentioned once, as the check on the three design choices.</a:t>
             </a:r>
             <a:endParaRPr lang="en-US" dirty="0"/>
           </a:p>
@@ -9380,7 +9380,7 @@
                 <a:ea typeface="Calibri" pitchFamily="34" charset="-122"/>
                 <a:cs typeface="Calibri" pitchFamily="34" charset="-120"/>
               </a:rPr>
-              <a:t>Feasibility: the core mechanism is already demonstrated</a:t>
+              <a:t>Why the proposed approach is feasible</a:t>
             </a:r>
             <a:endParaRPr lang="en-US" sz="2400" dirty="0"/>
           </a:p>
@@ -9419,7 +9419,7 @@
                 <a:ea typeface="Calibri" pitchFamily="34" charset="-122"/>
                 <a:cs typeface="Calibri" pitchFamily="34" charset="-120"/>
               </a:rPr>
-              <a:t>A working prototype, built with the AI Convergence Lab, shows the control layer end to end with real products and real assistants.</a:t>
+              <a:t>Three design choices keep the cost and the risk of the proposal low.</a:t>
             </a:r>
             <a:endParaRPr lang="en-US" sz="1100" dirty="0"/>
           </a:p>
@@ -9434,11 +9434,665 @@
         <p:spPr>
           <a:xfrm>
             <a:off x="411480" y="1325880"/>
-            <a:ext cx="2377440" cy="530352"/>
+            <a:ext cx="2651760" cy="2377440"/>
           </a:xfrm>
           <a:prstGeom prst="roundRect">
             <a:avLst>
-              <a:gd name="adj" fmla="val 10345"/>
+              <a:gd name="adj" fmla="val 2308"/>
+            </a:avLst>
+          </a:prstGeom>
+          <a:solidFill>
+            <a:srgbClr val="FFFFFF"/>
+          </a:solidFill>
+          <a:ln w="9525">
+            <a:solidFill>
+              <a:srgbClr val="D9E0EA"/>
+            </a:solidFill>
+            <a:prstDash val="solid"/>
+          </a:ln>
+        </p:spPr>
+      </p:sp>
+      <p:sp>
+        <p:nvSpPr>
+          <p:cNvPr id="6" name="Shape 4"/>
+          <p:cNvSpPr/>
+          <p:nvPr/>
+        </p:nvSpPr>
+        <p:spPr>
+          <a:xfrm>
+            <a:off x="594360" y="1508760"/>
+            <a:ext cx="402336" cy="402336"/>
+          </a:xfrm>
+          <a:prstGeom prst="ellipse">
+            <a:avLst/>
+          </a:prstGeom>
+          <a:solidFill>
+            <a:srgbClr val="0F766E"/>
+          </a:solidFill>
+          <a:ln w="12700">
+            <a:solidFill>
+              <a:srgbClr val="0F766E"/>
+            </a:solidFill>
+            <a:prstDash val="solid"/>
+          </a:ln>
+        </p:spPr>
+      </p:sp>
+      <p:pic>
+        <p:nvPicPr>
+          <p:cNvPr id="7" name="Image 0" descr="preencoded.png">    </p:cNvPr>
+          <p:cNvPicPr>
+            <a:picLocks noChangeAspect="1"/>
+          </p:cNvPicPr>
+          <p:nvPr/>
+        </p:nvPicPr>
+        <p:blipFill>
+          <a:blip r:embed="rId1"/>
+          <a:stretch>
+            <a:fillRect/>
+          </a:stretch>
+        </p:blipFill>
+        <p:spPr>
+          <a:xfrm>
+            <a:off x="694944" y="1609344"/>
+            <a:ext cx="201168" cy="201168"/>
+          </a:xfrm>
+          <a:prstGeom prst="rect">
+            <a:avLst/>
+          </a:prstGeom>
+        </p:spPr>
+      </p:pic>
+      <p:sp>
+        <p:nvSpPr>
+          <p:cNvPr id="8" name="Text 5"/>
+          <p:cNvSpPr txBox="1"/>
+          <p:nvPr/>
+        </p:nvSpPr>
+        <p:spPr>
+          <a:xfrm>
+            <a:off x="1124712" y="1508760"/>
+            <a:ext cx="1828800" cy="402336"/>
+          </a:xfrm>
+          <a:prstGeom prst="rect">
+            <a:avLst/>
+          </a:prstGeom>
+          <a:noFill/>
+          <a:ln/>
+        </p:spPr>
+        <p:txBody>
+          <a:bodyPr wrap="square" lIns="0" tIns="0" rIns="0" bIns="0" rtlCol="0" anchor="ctr"/>
+          <a:lstStyle/>
+          <a:p>
+            <a:pPr indent="0" marL="0">
+              <a:buNone/>
+            </a:pPr>
+            <a:r>
+              <a:rPr lang="en-US" sz="1200" b="1" dirty="0">
+                <a:solidFill>
+                  <a:srgbClr val="1C2433"/>
+                </a:solidFill>
+                <a:latin typeface="Calibri" pitchFamily="34" charset="0"/>
+                <a:ea typeface="Calibri" pitchFamily="34" charset="-122"/>
+                <a:cs typeface="Calibri" pitchFamily="34" charset="-120"/>
+              </a:rPr>
+              <a:t>Products are not modified</a:t>
+            </a:r>
+            <a:endParaRPr lang="en-US" sz="1200" dirty="0"/>
+          </a:p>
+        </p:txBody>
+      </p:sp>
+      <p:sp>
+        <p:nvSpPr>
+          <p:cNvPr id="9" name="Text 6"/>
+          <p:cNvSpPr txBox="1"/>
+          <p:nvPr/>
+        </p:nvSpPr>
+        <p:spPr>
+          <a:xfrm>
+            <a:off x="594360" y="2057400"/>
+            <a:ext cx="2286000" cy="1097280"/>
+          </a:xfrm>
+          <a:prstGeom prst="rect">
+            <a:avLst/>
+          </a:prstGeom>
+          <a:noFill/>
+          <a:ln/>
+        </p:spPr>
+        <p:txBody>
+          <a:bodyPr wrap="square" lIns="0" tIns="0" rIns="0" bIns="0" rtlCol="0" anchor="t"/>
+          <a:lstStyle/>
+          <a:p>
+            <a:pPr indent="0" marL="0">
+              <a:buNone/>
+            </a:pPr>
+            <a:r>
+              <a:rPr lang="en-US" sz="850" dirty="0">
+                <a:solidFill>
+                  <a:srgbClr val="4A5568"/>
+                </a:solidFill>
+                <a:latin typeface="Calibri" pitchFamily="34" charset="0"/>
+                <a:ea typeface="Calibri" pitchFamily="34" charset="-122"/>
+                <a:cs typeface="Calibri" pitchFamily="34" charset="-120"/>
+              </a:rPr>
+              <a:t>A product joins by registering the API description it already has. There is no development inside Bizplay, COOCON, FLOW or any other product team, so packages can be added one by one without a roadmap negotiation.</a:t>
+            </a:r>
+            <a:endParaRPr lang="en-US" sz="850" dirty="0"/>
+          </a:p>
+        </p:txBody>
+      </p:sp>
+      <p:sp>
+        <p:nvSpPr>
+          <p:cNvPr id="10" name="Shape 7"/>
+          <p:cNvSpPr/>
+          <p:nvPr/>
+        </p:nvSpPr>
+        <p:spPr>
+          <a:xfrm>
+            <a:off x="594360" y="3218688"/>
+            <a:ext cx="2286000" cy="9144"/>
+          </a:xfrm>
+          <a:prstGeom prst="rect">
+            <a:avLst/>
+          </a:prstGeom>
+          <a:solidFill>
+            <a:srgbClr val="D9E0EA"/>
+          </a:solidFill>
+          <a:ln w="12700">
+            <a:solidFill>
+              <a:srgbClr val="D9E0EA"/>
+            </a:solidFill>
+            <a:prstDash val="solid"/>
+          </a:ln>
+        </p:spPr>
+      </p:sp>
+      <p:sp>
+        <p:nvSpPr>
+          <p:cNvPr id="11" name="Text 8"/>
+          <p:cNvSpPr txBox="1"/>
+          <p:nvPr/>
+        </p:nvSpPr>
+        <p:spPr>
+          <a:xfrm>
+            <a:off x="594360" y="3273552"/>
+            <a:ext cx="2286000" cy="365760"/>
+          </a:xfrm>
+          <a:prstGeom prst="rect">
+            <a:avLst/>
+          </a:prstGeom>
+          <a:noFill/>
+          <a:ln/>
+        </p:spPr>
+        <p:txBody>
+          <a:bodyPr wrap="square" lIns="0" tIns="0" rIns="0" bIns="0" rtlCol="0" anchor="ctr"/>
+          <a:lstStyle/>
+          <a:p>
+            <a:pPr indent="0" marL="0">
+              <a:buNone/>
+            </a:pPr>
+            <a:r>
+              <a:rPr lang="en-US" sz="850" b="1" dirty="0">
+                <a:solidFill>
+                  <a:srgbClr val="0F766E"/>
+                </a:solidFill>
+                <a:latin typeface="Calibri" pitchFamily="34" charset="0"/>
+                <a:ea typeface="Calibri" pitchFamily="34" charset="-122"/>
+                <a:cs typeface="Calibri" pitchFamily="34" charset="-120"/>
+              </a:rPr>
+              <a:t>Effort per product: a registration and a policy review</a:t>
+            </a:r>
+            <a:endParaRPr lang="en-US" sz="850" dirty="0"/>
+          </a:p>
+        </p:txBody>
+      </p:sp>
+      <p:sp>
+        <p:nvSpPr>
+          <p:cNvPr id="12" name="Shape 9"/>
+          <p:cNvSpPr/>
+          <p:nvPr/>
+        </p:nvSpPr>
+        <p:spPr>
+          <a:xfrm>
+            <a:off x="3246120" y="1325880"/>
+            <a:ext cx="2651760" cy="2377440"/>
+          </a:xfrm>
+          <a:prstGeom prst="roundRect">
+            <a:avLst>
+              <a:gd name="adj" fmla="val 2308"/>
+            </a:avLst>
+          </a:prstGeom>
+          <a:solidFill>
+            <a:srgbClr val="FFFFFF"/>
+          </a:solidFill>
+          <a:ln w="9525">
+            <a:solidFill>
+              <a:srgbClr val="D9E0EA"/>
+            </a:solidFill>
+            <a:prstDash val="solid"/>
+          </a:ln>
+        </p:spPr>
+      </p:sp>
+      <p:sp>
+        <p:nvSpPr>
+          <p:cNvPr id="13" name="Shape 10"/>
+          <p:cNvSpPr/>
+          <p:nvPr/>
+        </p:nvSpPr>
+        <p:spPr>
+          <a:xfrm>
+            <a:off x="3429000" y="1508760"/>
+            <a:ext cx="402336" cy="402336"/>
+          </a:xfrm>
+          <a:prstGeom prst="ellipse">
+            <a:avLst/>
+          </a:prstGeom>
+          <a:solidFill>
+            <a:srgbClr val="14213D"/>
+          </a:solidFill>
+          <a:ln w="12700">
+            <a:solidFill>
+              <a:srgbClr val="14213D"/>
+            </a:solidFill>
+            <a:prstDash val="solid"/>
+          </a:ln>
+        </p:spPr>
+      </p:sp>
+      <p:pic>
+        <p:nvPicPr>
+          <p:cNvPr id="14" name="Image 1" descr="preencoded.png">    </p:cNvPr>
+          <p:cNvPicPr>
+            <a:picLocks noChangeAspect="1"/>
+          </p:cNvPicPr>
+          <p:nvPr/>
+        </p:nvPicPr>
+        <p:blipFill>
+          <a:blip r:embed="rId2"/>
+          <a:stretch>
+            <a:fillRect/>
+          </a:stretch>
+        </p:blipFill>
+        <p:spPr>
+          <a:xfrm>
+            <a:off x="3529584" y="1609344"/>
+            <a:ext cx="201168" cy="201168"/>
+          </a:xfrm>
+          <a:prstGeom prst="rect">
+            <a:avLst/>
+          </a:prstGeom>
+        </p:spPr>
+      </p:pic>
+      <p:sp>
+        <p:nvSpPr>
+          <p:cNvPr id="15" name="Text 11"/>
+          <p:cNvSpPr txBox="1"/>
+          <p:nvPr/>
+        </p:nvSpPr>
+        <p:spPr>
+          <a:xfrm>
+            <a:off x="3959352" y="1508760"/>
+            <a:ext cx="1828800" cy="402336"/>
+          </a:xfrm>
+          <a:prstGeom prst="rect">
+            <a:avLst/>
+          </a:prstGeom>
+          <a:noFill/>
+          <a:ln/>
+        </p:spPr>
+        <p:txBody>
+          <a:bodyPr wrap="square" lIns="0" tIns="0" rIns="0" bIns="0" rtlCol="0" anchor="ctr"/>
+          <a:lstStyle/>
+          <a:p>
+            <a:pPr indent="0" marL="0">
+              <a:buNone/>
+            </a:pPr>
+            <a:r>
+              <a:rPr lang="en-US" sz="1200" b="1" dirty="0">
+                <a:solidFill>
+                  <a:srgbClr val="1C2433"/>
+                </a:solidFill>
+                <a:latin typeface="Calibri" pitchFamily="34" charset="0"/>
+                <a:ea typeface="Calibri" pitchFamily="34" charset="-122"/>
+                <a:cs typeface="Calibri" pitchFamily="34" charset="-120"/>
+              </a:rPr>
+              <a:t>Built on open standards</a:t>
+            </a:r>
+            <a:endParaRPr lang="en-US" sz="1200" dirty="0"/>
+          </a:p>
+        </p:txBody>
+      </p:sp>
+      <p:sp>
+        <p:nvSpPr>
+          <p:cNvPr id="16" name="Text 12"/>
+          <p:cNvSpPr txBox="1"/>
+          <p:nvPr/>
+        </p:nvSpPr>
+        <p:spPr>
+          <a:xfrm>
+            <a:off x="3429000" y="2057400"/>
+            <a:ext cx="2286000" cy="1097280"/>
+          </a:xfrm>
+          <a:prstGeom prst="rect">
+            <a:avLst/>
+          </a:prstGeom>
+          <a:noFill/>
+          <a:ln/>
+        </p:spPr>
+        <p:txBody>
+          <a:bodyPr wrap="square" lIns="0" tIns="0" rIns="0" bIns="0" rtlCol="0" anchor="t"/>
+          <a:lstStyle/>
+          <a:p>
+            <a:pPr indent="0" marL="0">
+              <a:buNone/>
+            </a:pPr>
+            <a:r>
+              <a:rPr lang="en-US" sz="850" dirty="0">
+                <a:solidFill>
+                  <a:srgbClr val="4A5568"/>
+                </a:solidFill>
+                <a:latin typeface="Calibri" pitchFamily="34" charset="0"/>
+                <a:ea typeface="Calibri" pitchFamily="34" charset="-122"/>
+                <a:cs typeface="Calibri" pitchFamily="34" charset="-120"/>
+              </a:rPr>
+              <a:t>Tools are exposed through the Model Context Protocol and sign-in through OAuth 2.1. Claude, ChatGPT and Copilot already support both, so the group is not tied to one AI vendor and needs no custom client.</a:t>
+            </a:r>
+            <a:endParaRPr lang="en-US" sz="850" dirty="0"/>
+          </a:p>
+        </p:txBody>
+      </p:sp>
+      <p:sp>
+        <p:nvSpPr>
+          <p:cNvPr id="17" name="Shape 13"/>
+          <p:cNvSpPr/>
+          <p:nvPr/>
+        </p:nvSpPr>
+        <p:spPr>
+          <a:xfrm>
+            <a:off x="3429000" y="3218688"/>
+            <a:ext cx="2286000" cy="9144"/>
+          </a:xfrm>
+          <a:prstGeom prst="rect">
+            <a:avLst/>
+          </a:prstGeom>
+          <a:solidFill>
+            <a:srgbClr val="D9E0EA"/>
+          </a:solidFill>
+          <a:ln w="12700">
+            <a:solidFill>
+              <a:srgbClr val="D9E0EA"/>
+            </a:solidFill>
+            <a:prstDash val="solid"/>
+          </a:ln>
+        </p:spPr>
+      </p:sp>
+      <p:sp>
+        <p:nvSpPr>
+          <p:cNvPr id="18" name="Text 14"/>
+          <p:cNvSpPr txBox="1"/>
+          <p:nvPr/>
+        </p:nvSpPr>
+        <p:spPr>
+          <a:xfrm>
+            <a:off x="3429000" y="3273552"/>
+            <a:ext cx="2286000" cy="365760"/>
+          </a:xfrm>
+          <a:prstGeom prst="rect">
+            <a:avLst/>
+          </a:prstGeom>
+          <a:noFill/>
+          <a:ln/>
+        </p:spPr>
+        <p:txBody>
+          <a:bodyPr wrap="square" lIns="0" tIns="0" rIns="0" bIns="0" rtlCol="0" anchor="ctr"/>
+          <a:lstStyle/>
+          <a:p>
+            <a:pPr indent="0" marL="0">
+              <a:buNone/>
+            </a:pPr>
+            <a:r>
+              <a:rPr lang="en-US" sz="850" b="1" dirty="0">
+                <a:solidFill>
+                  <a:srgbClr val="14213D"/>
+                </a:solidFill>
+                <a:latin typeface="Calibri" pitchFamily="34" charset="0"/>
+                <a:ea typeface="Calibri" pitchFamily="34" charset="-122"/>
+                <a:cs typeface="Calibri" pitchFamily="34" charset="-120"/>
+              </a:rPr>
+              <a:t>One integration serves every assistant</a:t>
+            </a:r>
+            <a:endParaRPr lang="en-US" sz="850" dirty="0"/>
+          </a:p>
+        </p:txBody>
+      </p:sp>
+      <p:sp>
+        <p:nvSpPr>
+          <p:cNvPr id="19" name="Shape 15"/>
+          <p:cNvSpPr/>
+          <p:nvPr/>
+        </p:nvSpPr>
+        <p:spPr>
+          <a:xfrm>
+            <a:off x="6080760" y="1325880"/>
+            <a:ext cx="2651760" cy="2377440"/>
+          </a:xfrm>
+          <a:prstGeom prst="roundRect">
+            <a:avLst>
+              <a:gd name="adj" fmla="val 2308"/>
+            </a:avLst>
+          </a:prstGeom>
+          <a:solidFill>
+            <a:srgbClr val="FFFFFF"/>
+          </a:solidFill>
+          <a:ln w="9525">
+            <a:solidFill>
+              <a:srgbClr val="D9E0EA"/>
+            </a:solidFill>
+            <a:prstDash val="solid"/>
+          </a:ln>
+        </p:spPr>
+      </p:sp>
+      <p:sp>
+        <p:nvSpPr>
+          <p:cNvPr id="20" name="Shape 16"/>
+          <p:cNvSpPr/>
+          <p:nvPr/>
+        </p:nvSpPr>
+        <p:spPr>
+          <a:xfrm>
+            <a:off x="6263640" y="1508760"/>
+            <a:ext cx="402336" cy="402336"/>
+          </a:xfrm>
+          <a:prstGeom prst="ellipse">
+            <a:avLst/>
+          </a:prstGeom>
+          <a:solidFill>
+            <a:srgbClr val="B45309"/>
+          </a:solidFill>
+          <a:ln w="12700">
+            <a:solidFill>
+              <a:srgbClr val="B45309"/>
+            </a:solidFill>
+            <a:prstDash val="solid"/>
+          </a:ln>
+        </p:spPr>
+      </p:sp>
+      <p:pic>
+        <p:nvPicPr>
+          <p:cNvPr id="21" name="Image 2" descr="preencoded.png">    </p:cNvPr>
+          <p:cNvPicPr>
+            <a:picLocks noChangeAspect="1"/>
+          </p:cNvPicPr>
+          <p:nvPr/>
+        </p:nvPicPr>
+        <p:blipFill>
+          <a:blip r:embed="rId3"/>
+          <a:stretch>
+            <a:fillRect/>
+          </a:stretch>
+        </p:blipFill>
+        <p:spPr>
+          <a:xfrm>
+            <a:off x="6364224" y="1609344"/>
+            <a:ext cx="201168" cy="201168"/>
+          </a:xfrm>
+          <a:prstGeom prst="rect">
+            <a:avLst/>
+          </a:prstGeom>
+        </p:spPr>
+      </p:pic>
+      <p:sp>
+        <p:nvSpPr>
+          <p:cNvPr id="22" name="Text 17"/>
+          <p:cNvSpPr txBox="1"/>
+          <p:nvPr/>
+        </p:nvSpPr>
+        <p:spPr>
+          <a:xfrm>
+            <a:off x="6793992" y="1508760"/>
+            <a:ext cx="1828800" cy="402336"/>
+          </a:xfrm>
+          <a:prstGeom prst="rect">
+            <a:avLst/>
+          </a:prstGeom>
+          <a:noFill/>
+          <a:ln/>
+        </p:spPr>
+        <p:txBody>
+          <a:bodyPr wrap="square" lIns="0" tIns="0" rIns="0" bIns="0" rtlCol="0" anchor="ctr"/>
+          <a:lstStyle/>
+          <a:p>
+            <a:pPr indent="0" marL="0">
+              <a:buNone/>
+            </a:pPr>
+            <a:r>
+              <a:rPr lang="en-US" sz="1200" b="1" dirty="0">
+                <a:solidFill>
+                  <a:srgbClr val="1C2433"/>
+                </a:solidFill>
+                <a:latin typeface="Calibri" pitchFamily="34" charset="0"/>
+                <a:ea typeface="Calibri" pitchFamily="34" charset="-122"/>
+                <a:cs typeface="Calibri" pitchFamily="34" charset="-120"/>
+              </a:rPr>
+              <a:t>Existing controls are reused</a:t>
+            </a:r>
+            <a:endParaRPr lang="en-US" sz="1200" dirty="0"/>
+          </a:p>
+        </p:txBody>
+      </p:sp>
+      <p:sp>
+        <p:nvSpPr>
+          <p:cNvPr id="23" name="Text 18"/>
+          <p:cNvSpPr txBox="1"/>
+          <p:nvPr/>
+        </p:nvSpPr>
+        <p:spPr>
+          <a:xfrm>
+            <a:off x="6263640" y="2057400"/>
+            <a:ext cx="2286000" cy="1097280"/>
+          </a:xfrm>
+          <a:prstGeom prst="rect">
+            <a:avLst/>
+          </a:prstGeom>
+          <a:noFill/>
+          <a:ln/>
+        </p:spPr>
+        <p:txBody>
+          <a:bodyPr wrap="square" lIns="0" tIns="0" rIns="0" bIns="0" rtlCol="0" anchor="t"/>
+          <a:lstStyle/>
+          <a:p>
+            <a:pPr indent="0" marL="0">
+              <a:buNone/>
+            </a:pPr>
+            <a:r>
+              <a:rPr lang="en-US" sz="850" dirty="0">
+                <a:solidFill>
+                  <a:srgbClr val="4A5568"/>
+                </a:solidFill>
+                <a:latin typeface="Calibri" pitchFamily="34" charset="0"/>
+                <a:ea typeface="Calibri" pitchFamily="34" charset="-122"/>
+                <a:cs typeface="Calibri" pitchFamily="34" charset="-120"/>
+              </a:rPr>
+              <a:t>Product permissions, credentials and approval lines stay where they are. The gateway adds what is missing on top: who is asking, what they may do, and a record of it. Payments never bypass approval.</a:t>
+            </a:r>
+            <a:endParaRPr lang="en-US" sz="850" dirty="0"/>
+          </a:p>
+        </p:txBody>
+      </p:sp>
+      <p:sp>
+        <p:nvSpPr>
+          <p:cNvPr id="24" name="Shape 19"/>
+          <p:cNvSpPr/>
+          <p:nvPr/>
+        </p:nvSpPr>
+        <p:spPr>
+          <a:xfrm>
+            <a:off x="6263640" y="3218688"/>
+            <a:ext cx="2286000" cy="9144"/>
+          </a:xfrm>
+          <a:prstGeom prst="rect">
+            <a:avLst/>
+          </a:prstGeom>
+          <a:solidFill>
+            <a:srgbClr val="D9E0EA"/>
+          </a:solidFill>
+          <a:ln w="12700">
+            <a:solidFill>
+              <a:srgbClr val="D9E0EA"/>
+            </a:solidFill>
+            <a:prstDash val="solid"/>
+          </a:ln>
+        </p:spPr>
+      </p:sp>
+      <p:sp>
+        <p:nvSpPr>
+          <p:cNvPr id="25" name="Text 20"/>
+          <p:cNvSpPr txBox="1"/>
+          <p:nvPr/>
+        </p:nvSpPr>
+        <p:spPr>
+          <a:xfrm>
+            <a:off x="6263640" y="3273552"/>
+            <a:ext cx="2286000" cy="365760"/>
+          </a:xfrm>
+          <a:prstGeom prst="rect">
+            <a:avLst/>
+          </a:prstGeom>
+          <a:noFill/>
+          <a:ln/>
+        </p:spPr>
+        <p:txBody>
+          <a:bodyPr wrap="square" lIns="0" tIns="0" rIns="0" bIns="0" rtlCol="0" anchor="ctr"/>
+          <a:lstStyle/>
+          <a:p>
+            <a:pPr indent="0" marL="0">
+              <a:buNone/>
+            </a:pPr>
+            <a:r>
+              <a:rPr lang="en-US" sz="850" b="1" dirty="0">
+                <a:solidFill>
+                  <a:srgbClr val="B45309"/>
+                </a:solidFill>
+                <a:latin typeface="Calibri" pitchFamily="34" charset="0"/>
+                <a:ea typeface="Calibri" pitchFamily="34" charset="-122"/>
+                <a:cs typeface="Calibri" pitchFamily="34" charset="-120"/>
+              </a:rPr>
+              <a:t>No new path around today's controls</a:t>
+            </a:r>
+            <a:endParaRPr lang="en-US" sz="850" dirty="0"/>
+          </a:p>
+        </p:txBody>
+      </p:sp>
+      <p:sp>
+        <p:nvSpPr>
+          <p:cNvPr id="26" name="Shape 21"/>
+          <p:cNvSpPr/>
+          <p:nvPr/>
+        </p:nvSpPr>
+        <p:spPr>
+          <a:xfrm>
+            <a:off x="411480" y="3858768"/>
+            <a:ext cx="8321040" cy="804672"/>
+          </a:xfrm>
+          <a:prstGeom prst="roundRect">
+            <a:avLst>
+              <a:gd name="adj" fmla="val 6818"/>
             </a:avLst>
           </a:prstGeom>
           <a:solidFill>
@@ -9454,30 +10108,30 @@
       </p:sp>
       <p:sp>
         <p:nvSpPr>
-          <p:cNvPr id="6" name="Text 4"/>
-          <p:cNvSpPr txBox="1"/>
-          <p:nvPr/>
-        </p:nvSpPr>
-        <p:spPr>
-          <a:xfrm>
-            <a:off x="594360" y="1325880"/>
-            <a:ext cx="822960" cy="530352"/>
-          </a:xfrm>
-          <a:prstGeom prst="rect">
-            <a:avLst/>
-          </a:prstGeom>
-          <a:noFill/>
-          <a:ln/>
-        </p:spPr>
-        <p:txBody>
-          <a:bodyPr wrap="square" lIns="0" tIns="0" rIns="0" bIns="0" rtlCol="0" anchor="ctr"/>
-          <a:lstStyle/>
-          <a:p>
-            <a:pPr indent="0" marL="0">
-              <a:buNone/>
-            </a:pPr>
-            <a:r>
-              <a:rPr lang="en-US" sz="2200" b="1" dirty="0">
+          <p:cNvPr id="27" name="Text 22"/>
+          <p:cNvSpPr txBox="1"/>
+          <p:nvPr/>
+        </p:nvSpPr>
+        <p:spPr>
+          <a:xfrm>
+            <a:off x="594360" y="3931920"/>
+            <a:ext cx="3657600" cy="182880"/>
+          </a:xfrm>
+          <a:prstGeom prst="rect">
+            <a:avLst/>
+          </a:prstGeom>
+          <a:noFill/>
+          <a:ln/>
+        </p:spPr>
+        <p:txBody>
+          <a:bodyPr wrap="square" lIns="0" tIns="0" rIns="0" bIns="0" rtlCol="0" anchor="ctr"/>
+          <a:lstStyle/>
+          <a:p>
+            <a:pPr indent="0" marL="0">
+              <a:buNone/>
+            </a:pPr>
+            <a:r>
+              <a:rPr lang="en-US" sz="800" b="1" spc="100" kern="0" dirty="0">
                 <a:solidFill>
                   <a:srgbClr val="0F766E"/>
                 </a:solidFill>
@@ -9485,46 +10139,46 @@
                 <a:ea typeface="Calibri" pitchFamily="34" charset="-122"/>
                 <a:cs typeface="Calibri" pitchFamily="34" charset="-120"/>
               </a:rPr>
-              <a:t>4</a:t>
-            </a:r>
-            <a:endParaRPr lang="en-US" sz="2200" dirty="0"/>
-          </a:p>
-        </p:txBody>
-      </p:sp>
-      <p:sp>
-        <p:nvSpPr>
-          <p:cNvPr id="7" name="Text 5"/>
-          <p:cNvSpPr txBox="1"/>
-          <p:nvPr/>
-        </p:nvSpPr>
-        <p:spPr>
-          <a:xfrm>
-            <a:off x="1371600" y="1325880"/>
-            <a:ext cx="1371600" cy="530352"/>
-          </a:xfrm>
-          <a:prstGeom prst="rect">
-            <a:avLst/>
-          </a:prstGeom>
-          <a:noFill/>
-          <a:ln/>
-        </p:spPr>
-        <p:txBody>
-          <a:bodyPr wrap="square" lIns="0" tIns="0" rIns="0" bIns="0" rtlCol="0" anchor="ctr"/>
-          <a:lstStyle/>
-          <a:p>
-            <a:pPr indent="0" marL="0">
-              <a:buNone/>
-            </a:pPr>
-            <a:r>
-              <a:rPr lang="en-US" sz="850" b="1" dirty="0">
-                <a:solidFill>
-                  <a:srgbClr val="1C2433"/>
-                </a:solidFill>
-                <a:latin typeface="Calibri" pitchFamily="34" charset="0"/>
-                <a:ea typeface="Calibri" pitchFamily="34" charset="-122"/>
-                <a:cs typeface="Calibri" pitchFamily="34" charset="-120"/>
-              </a:rPr>
-              <a:t>products behind one address</a:t>
+              <a:t>CHECKED IN A LAB PROTOTYPE</a:t>
+            </a:r>
+            <a:endParaRPr lang="en-US" sz="800" dirty="0"/>
+          </a:p>
+        </p:txBody>
+      </p:sp>
+      <p:sp>
+        <p:nvSpPr>
+          <p:cNvPr id="28" name="Text 23"/>
+          <p:cNvSpPr txBox="1"/>
+          <p:nvPr/>
+        </p:nvSpPr>
+        <p:spPr>
+          <a:xfrm>
+            <a:off x="594360" y="4114800"/>
+            <a:ext cx="7955280" cy="502920"/>
+          </a:xfrm>
+          <a:prstGeom prst="rect">
+            <a:avLst/>
+          </a:prstGeom>
+          <a:noFill/>
+          <a:ln/>
+        </p:spPr>
+        <p:txBody>
+          <a:bodyPr wrap="square" lIns="0" tIns="0" rIns="0" bIns="0" rtlCol="0" anchor="ctr"/>
+          <a:lstStyle/>
+          <a:p>
+            <a:pPr indent="0" marL="0">
+              <a:buNone/>
+            </a:pPr>
+            <a:r>
+              <a:rPr lang="en-US" sz="850" dirty="0">
+                <a:solidFill>
+                  <a:srgbClr val="4A5568"/>
+                </a:solidFill>
+                <a:latin typeface="Calibri" pitchFamily="34" charset="0"/>
+                <a:ea typeface="Calibri" pitchFamily="34" charset="-122"/>
+                <a:cs typeface="Calibri" pitchFamily="34" charset="-120"/>
+              </a:rPr>
+              <a:t>A prototype built with the AI Convergence Lab confirmed all three choices with four products and two assistants. The open risks are group single sign-on, approval-line integration, production scale and validation with real customer departments. They are the proposed work on the next slide.</a:t>
             </a:r>
             <a:endParaRPr lang="en-US" sz="850" dirty="0"/>
           </a:p>
@@ -9532,629 +10186,7 @@
       </p:sp>
       <p:sp>
         <p:nvSpPr>
-          <p:cNvPr id="8" name="Shape 6"/>
-          <p:cNvSpPr/>
-          <p:nvPr/>
-        </p:nvSpPr>
-        <p:spPr>
-          <a:xfrm>
-            <a:off x="411480" y="1929384"/>
-            <a:ext cx="2377440" cy="530352"/>
-          </a:xfrm>
-          <a:prstGeom prst="roundRect">
-            <a:avLst>
-              <a:gd name="adj" fmla="val 10345"/>
-            </a:avLst>
-          </a:prstGeom>
-          <a:solidFill>
-            <a:srgbClr val="F5F7FA"/>
-          </a:solidFill>
-          <a:ln w="9525">
-            <a:solidFill>
-              <a:srgbClr val="D9E0EA"/>
-            </a:solidFill>
-            <a:prstDash val="solid"/>
-          </a:ln>
-        </p:spPr>
-      </p:sp>
-      <p:sp>
-        <p:nvSpPr>
-          <p:cNvPr id="9" name="Text 7"/>
-          <p:cNvSpPr txBox="1"/>
-          <p:nvPr/>
-        </p:nvSpPr>
-        <p:spPr>
-          <a:xfrm>
-            <a:off x="594360" y="1929384"/>
-            <a:ext cx="822960" cy="530352"/>
-          </a:xfrm>
-          <a:prstGeom prst="rect">
-            <a:avLst/>
-          </a:prstGeom>
-          <a:noFill/>
-          <a:ln/>
-        </p:spPr>
-        <p:txBody>
-          <a:bodyPr wrap="square" lIns="0" tIns="0" rIns="0" bIns="0" rtlCol="0" anchor="ctr"/>
-          <a:lstStyle/>
-          <a:p>
-            <a:pPr indent="0" marL="0">
-              <a:buNone/>
-            </a:pPr>
-            <a:r>
-              <a:rPr lang="en-US" sz="2200" b="1" dirty="0">
-                <a:solidFill>
-                  <a:srgbClr val="0F766E"/>
-                </a:solidFill>
-                <a:latin typeface="Calibri" pitchFamily="34" charset="0"/>
-                <a:ea typeface="Calibri" pitchFamily="34" charset="-122"/>
-                <a:cs typeface="Calibri" pitchFamily="34" charset="-120"/>
-              </a:rPr>
-              <a:t>72</a:t>
-            </a:r>
-            <a:endParaRPr lang="en-US" sz="2200" dirty="0"/>
-          </a:p>
-        </p:txBody>
-      </p:sp>
-      <p:sp>
-        <p:nvSpPr>
-          <p:cNvPr id="10" name="Text 8"/>
-          <p:cNvSpPr txBox="1"/>
-          <p:nvPr/>
-        </p:nvSpPr>
-        <p:spPr>
-          <a:xfrm>
-            <a:off x="1371600" y="1929384"/>
-            <a:ext cx="1371600" cy="530352"/>
-          </a:xfrm>
-          <a:prstGeom prst="rect">
-            <a:avLst/>
-          </a:prstGeom>
-          <a:noFill/>
-          <a:ln/>
-        </p:spPr>
-        <p:txBody>
-          <a:bodyPr wrap="square" lIns="0" tIns="0" rIns="0" bIns="0" rtlCol="0" anchor="ctr"/>
-          <a:lstStyle/>
-          <a:p>
-            <a:pPr indent="0" marL="0">
-              <a:buNone/>
-            </a:pPr>
-            <a:r>
-              <a:rPr lang="en-US" sz="850" b="1" dirty="0">
-                <a:solidFill>
-                  <a:srgbClr val="1C2433"/>
-                </a:solidFill>
-                <a:latin typeface="Calibri" pitchFamily="34" charset="0"/>
-                <a:ea typeface="Calibri" pitchFamily="34" charset="-122"/>
-                <a:cs typeface="Calibri" pitchFamily="34" charset="-120"/>
-              </a:rPr>
-              <a:t>tools, with no product code changed</a:t>
-            </a:r>
-            <a:endParaRPr lang="en-US" sz="850" dirty="0"/>
-          </a:p>
-        </p:txBody>
-      </p:sp>
-      <p:sp>
-        <p:nvSpPr>
-          <p:cNvPr id="11" name="Shape 9"/>
-          <p:cNvSpPr/>
-          <p:nvPr/>
-        </p:nvSpPr>
-        <p:spPr>
-          <a:xfrm>
-            <a:off x="411480" y="2532888"/>
-            <a:ext cx="2377440" cy="530352"/>
-          </a:xfrm>
-          <a:prstGeom prst="roundRect">
-            <a:avLst>
-              <a:gd name="adj" fmla="val 10345"/>
-            </a:avLst>
-          </a:prstGeom>
-          <a:solidFill>
-            <a:srgbClr val="F5F7FA"/>
-          </a:solidFill>
-          <a:ln w="9525">
-            <a:solidFill>
-              <a:srgbClr val="D9E0EA"/>
-            </a:solidFill>
-            <a:prstDash val="solid"/>
-          </a:ln>
-        </p:spPr>
-      </p:sp>
-      <p:sp>
-        <p:nvSpPr>
-          <p:cNvPr id="12" name="Text 10"/>
-          <p:cNvSpPr txBox="1"/>
-          <p:nvPr/>
-        </p:nvSpPr>
-        <p:spPr>
-          <a:xfrm>
-            <a:off x="594360" y="2532888"/>
-            <a:ext cx="822960" cy="530352"/>
-          </a:xfrm>
-          <a:prstGeom prst="rect">
-            <a:avLst/>
-          </a:prstGeom>
-          <a:noFill/>
-          <a:ln/>
-        </p:spPr>
-        <p:txBody>
-          <a:bodyPr wrap="square" lIns="0" tIns="0" rIns="0" bIns="0" rtlCol="0" anchor="ctr"/>
-          <a:lstStyle/>
-          <a:p>
-            <a:pPr indent="0" marL="0">
-              <a:buNone/>
-            </a:pPr>
-            <a:r>
-              <a:rPr lang="en-US" sz="2200" b="1" dirty="0">
-                <a:solidFill>
-                  <a:srgbClr val="0F766E"/>
-                </a:solidFill>
-                <a:latin typeface="Calibri" pitchFamily="34" charset="0"/>
-                <a:ea typeface="Calibri" pitchFamily="34" charset="-122"/>
-                <a:cs typeface="Calibri" pitchFamily="34" charset="-120"/>
-              </a:rPr>
-              <a:t>1</a:t>
-            </a:r>
-            <a:endParaRPr lang="en-US" sz="2200" dirty="0"/>
-          </a:p>
-        </p:txBody>
-      </p:sp>
-      <p:sp>
-        <p:nvSpPr>
-          <p:cNvPr id="13" name="Text 11"/>
-          <p:cNvSpPr txBox="1"/>
-          <p:nvPr/>
-        </p:nvSpPr>
-        <p:spPr>
-          <a:xfrm>
-            <a:off x="1371600" y="2532888"/>
-            <a:ext cx="1371600" cy="530352"/>
-          </a:xfrm>
-          <a:prstGeom prst="rect">
-            <a:avLst/>
-          </a:prstGeom>
-          <a:noFill/>
-          <a:ln/>
-        </p:spPr>
-        <p:txBody>
-          <a:bodyPr wrap="square" lIns="0" tIns="0" rIns="0" bIns="0" rtlCol="0" anchor="ctr"/>
-          <a:lstStyle/>
-          <a:p>
-            <a:pPr indent="0" marL="0">
-              <a:buNone/>
-            </a:pPr>
-            <a:r>
-              <a:rPr lang="en-US" sz="850" b="1" dirty="0">
-                <a:solidFill>
-                  <a:srgbClr val="1C2433"/>
-                </a:solidFill>
-                <a:latin typeface="Calibri" pitchFamily="34" charset="0"/>
-                <a:ea typeface="Calibri" pitchFamily="34" charset="-122"/>
-                <a:cs typeface="Calibri" pitchFamily="34" charset="-120"/>
-              </a:rPr>
-              <a:t>sign-in for the customer</a:t>
-            </a:r>
-            <a:endParaRPr lang="en-US" sz="850" dirty="0"/>
-          </a:p>
-        </p:txBody>
-      </p:sp>
-      <p:sp>
-        <p:nvSpPr>
-          <p:cNvPr id="14" name="Shape 12"/>
-          <p:cNvSpPr/>
-          <p:nvPr/>
-        </p:nvSpPr>
-        <p:spPr>
-          <a:xfrm>
-            <a:off x="411480" y="3136392"/>
-            <a:ext cx="2377440" cy="530352"/>
-          </a:xfrm>
-          <a:prstGeom prst="roundRect">
-            <a:avLst>
-              <a:gd name="adj" fmla="val 10345"/>
-            </a:avLst>
-          </a:prstGeom>
-          <a:solidFill>
-            <a:srgbClr val="F5F7FA"/>
-          </a:solidFill>
-          <a:ln w="9525">
-            <a:solidFill>
-              <a:srgbClr val="D9E0EA"/>
-            </a:solidFill>
-            <a:prstDash val="solid"/>
-          </a:ln>
-        </p:spPr>
-      </p:sp>
-      <p:sp>
-        <p:nvSpPr>
-          <p:cNvPr id="15" name="Text 13"/>
-          <p:cNvSpPr txBox="1"/>
-          <p:nvPr/>
-        </p:nvSpPr>
-        <p:spPr>
-          <a:xfrm>
-            <a:off x="594360" y="3136392"/>
-            <a:ext cx="822960" cy="530352"/>
-          </a:xfrm>
-          <a:prstGeom prst="rect">
-            <a:avLst/>
-          </a:prstGeom>
-          <a:noFill/>
-          <a:ln/>
-        </p:spPr>
-        <p:txBody>
-          <a:bodyPr wrap="square" lIns="0" tIns="0" rIns="0" bIns="0" rtlCol="0" anchor="ctr"/>
-          <a:lstStyle/>
-          <a:p>
-            <a:pPr indent="0" marL="0">
-              <a:buNone/>
-            </a:pPr>
-            <a:r>
-              <a:rPr lang="en-US" sz="2200" b="1" dirty="0">
-                <a:solidFill>
-                  <a:srgbClr val="0F766E"/>
-                </a:solidFill>
-                <a:latin typeface="Calibri" pitchFamily="34" charset="0"/>
-                <a:ea typeface="Calibri" pitchFamily="34" charset="-122"/>
-                <a:cs typeface="Calibri" pitchFamily="34" charset="-120"/>
-              </a:rPr>
-              <a:t>0</a:t>
-            </a:r>
-            <a:endParaRPr lang="en-US" sz="2200" dirty="0"/>
-          </a:p>
-        </p:txBody>
-      </p:sp>
-      <p:sp>
-        <p:nvSpPr>
-          <p:cNvPr id="16" name="Text 14"/>
-          <p:cNvSpPr txBox="1"/>
-          <p:nvPr/>
-        </p:nvSpPr>
-        <p:spPr>
-          <a:xfrm>
-            <a:off x="1371600" y="3136392"/>
-            <a:ext cx="1371600" cy="530352"/>
-          </a:xfrm>
-          <a:prstGeom prst="rect">
-            <a:avLst/>
-          </a:prstGeom>
-          <a:noFill/>
-          <a:ln/>
-        </p:spPr>
-        <p:txBody>
-          <a:bodyPr wrap="square" lIns="0" tIns="0" rIns="0" bIns="0" rtlCol="0" anchor="ctr"/>
-          <a:lstStyle/>
-          <a:p>
-            <a:pPr indent="0" marL="0">
-              <a:buNone/>
-            </a:pPr>
-            <a:r>
-              <a:rPr lang="en-US" sz="850" b="1" dirty="0">
-                <a:solidFill>
-                  <a:srgbClr val="1C2433"/>
-                </a:solidFill>
-                <a:latin typeface="Calibri" pitchFamily="34" charset="0"/>
-                <a:ea typeface="Calibri" pitchFamily="34" charset="-122"/>
-                <a:cs typeface="Calibri" pitchFamily="34" charset="-120"/>
-              </a:rPr>
-              <a:t>changes to the products</a:t>
-            </a:r>
-            <a:endParaRPr lang="en-US" sz="850" dirty="0"/>
-          </a:p>
-        </p:txBody>
-      </p:sp>
-      <p:sp>
-        <p:nvSpPr>
-          <p:cNvPr id="17" name="Shape 15"/>
-          <p:cNvSpPr/>
-          <p:nvPr/>
-        </p:nvSpPr>
-        <p:spPr>
-          <a:xfrm>
-            <a:off x="2962656" y="1610513"/>
-            <a:ext cx="5824728" cy="1625294"/>
-          </a:xfrm>
-          <a:prstGeom prst="roundRect">
-            <a:avLst>
-              <a:gd name="adj" fmla="val 3376"/>
-            </a:avLst>
-          </a:prstGeom>
-          <a:solidFill>
-            <a:srgbClr val="FFFFFF"/>
-          </a:solidFill>
-          <a:ln w="9525">
-            <a:solidFill>
-              <a:srgbClr val="D9E0EA"/>
-            </a:solidFill>
-            <a:prstDash val="solid"/>
-          </a:ln>
-          <a:effectLst>
-            <a:outerShdw sx="100000" sy="100000" kx="0" ky="0" algn="bl" rotWithShape="0" blurRad="101600" dist="38100" dir="5400000">
-              <a:srgbClr val="14213D">
-                <a:alpha val="18000"/>
-              </a:srgbClr>
-            </a:outerShdw>
-          </a:effectLst>
-        </p:spPr>
-      </p:sp>
-      <p:pic>
-        <p:nvPicPr>
-          <p:cNvPr id="18" name="Image 0" descr="C:\Users\user\AppData\Local\Temp\deckcrops\overview-3.png">    </p:cNvPr>
-          <p:cNvPicPr>
-            <a:picLocks noChangeAspect="1"/>
-          </p:cNvPicPr>
-          <p:nvPr/>
-        </p:nvPicPr>
-        <p:blipFill>
-          <a:blip r:embed="rId1"/>
-          <a:stretch>
-            <a:fillRect/>
-          </a:stretch>
-        </p:blipFill>
-        <p:spPr>
-          <a:xfrm>
-            <a:off x="3017520" y="1665377"/>
-            <a:ext cx="5715000" cy="1515566"/>
-          </a:xfrm>
-          <a:prstGeom prst="rect">
-            <a:avLst/>
-          </a:prstGeom>
-        </p:spPr>
-      </p:pic>
-      <p:sp>
-        <p:nvSpPr>
-          <p:cNvPr id="19" name="Text 16"/>
-          <p:cNvSpPr txBox="1"/>
-          <p:nvPr/>
-        </p:nvSpPr>
-        <p:spPr>
-          <a:xfrm>
-            <a:off x="3017520" y="3235807"/>
-            <a:ext cx="5715000" cy="182880"/>
-          </a:xfrm>
-          <a:prstGeom prst="rect">
-            <a:avLst/>
-          </a:prstGeom>
-          <a:noFill/>
-          <a:ln/>
-        </p:spPr>
-        <p:txBody>
-          <a:bodyPr wrap="square" lIns="0" tIns="0" rIns="0" bIns="0" rtlCol="0" anchor="ctr"/>
-          <a:lstStyle/>
-          <a:p>
-            <a:pPr algn="ctr" indent="0" marL="0">
-              <a:buNone/>
-            </a:pPr>
-            <a:r>
-              <a:rPr lang="en-US" sz="750" i="1" dirty="0">
-                <a:solidFill>
-                  <a:srgbClr val="7A8593"/>
-                </a:solidFill>
-                <a:latin typeface="Calibri" pitchFamily="34" charset="0"/>
-                <a:ea typeface="Calibri" pitchFamily="34" charset="-122"/>
-                <a:cs typeface="Calibri" pitchFamily="34" charset="-120"/>
-              </a:rPr>
-              <a:t>Prototype portal: assistant calls per day through the gateway, allowed, denied and failed</a:t>
-            </a:r>
-            <a:endParaRPr lang="en-US" sz="750" dirty="0"/>
-          </a:p>
-        </p:txBody>
-      </p:sp>
-      <p:sp>
-        <p:nvSpPr>
-          <p:cNvPr id="20" name="Shape 17"/>
-          <p:cNvSpPr/>
-          <p:nvPr/>
-        </p:nvSpPr>
-        <p:spPr>
-          <a:xfrm>
-            <a:off x="411480" y="3840480"/>
-            <a:ext cx="4069080" cy="841248"/>
-          </a:xfrm>
-          <a:prstGeom prst="roundRect">
-            <a:avLst>
-              <a:gd name="adj" fmla="val 6522"/>
-            </a:avLst>
-          </a:prstGeom>
-          <a:solidFill>
-            <a:srgbClr val="E6F4F1"/>
-          </a:solidFill>
-          <a:ln w="9525">
-            <a:solidFill>
-              <a:srgbClr val="0F766E"/>
-            </a:solidFill>
-            <a:prstDash val="solid"/>
-          </a:ln>
-        </p:spPr>
-      </p:sp>
-      <p:sp>
-        <p:nvSpPr>
-          <p:cNvPr id="21" name="Text 18"/>
-          <p:cNvSpPr txBox="1"/>
-          <p:nvPr/>
-        </p:nvSpPr>
-        <p:spPr>
-          <a:xfrm>
-            <a:off x="566928" y="3904488"/>
-            <a:ext cx="3657600" cy="182880"/>
-          </a:xfrm>
-          <a:prstGeom prst="rect">
-            <a:avLst/>
-          </a:prstGeom>
-          <a:noFill/>
-          <a:ln/>
-        </p:spPr>
-        <p:txBody>
-          <a:bodyPr wrap="square" lIns="0" tIns="0" rIns="0" bIns="0" rtlCol="0" anchor="ctr"/>
-          <a:lstStyle/>
-          <a:p>
-            <a:pPr indent="0" marL="0">
-              <a:buNone/>
-            </a:pPr>
-            <a:r>
-              <a:rPr lang="en-US" sz="800" b="1" spc="100" kern="0" dirty="0">
-                <a:solidFill>
-                  <a:srgbClr val="0F766E"/>
-                </a:solidFill>
-                <a:latin typeface="Calibri" pitchFamily="34" charset="0"/>
-                <a:ea typeface="Calibri" pitchFamily="34" charset="-122"/>
-                <a:cs typeface="Calibri" pitchFamily="34" charset="-120"/>
-              </a:rPr>
-              <a:t>WHAT THE PROTOTYPE SHOWS</a:t>
-            </a:r>
-            <a:endParaRPr lang="en-US" sz="800" dirty="0"/>
-          </a:p>
-        </p:txBody>
-      </p:sp>
-      <p:sp>
-        <p:nvSpPr>
-          <p:cNvPr id="22" name="Text 19"/>
-          <p:cNvSpPr txBox="1"/>
-          <p:nvPr/>
-        </p:nvSpPr>
-        <p:spPr>
-          <a:xfrm>
-            <a:off x="566928" y="4096512"/>
-            <a:ext cx="3749040" cy="548640"/>
-          </a:xfrm>
-          <a:prstGeom prst="rect">
-            <a:avLst/>
-          </a:prstGeom>
-          <a:noFill/>
-          <a:ln/>
-        </p:spPr>
-        <p:txBody>
-          <a:bodyPr wrap="square" lIns="0" tIns="0" rIns="0" bIns="0" rtlCol="0" anchor="ctr"/>
-          <a:lstStyle/>
-          <a:p>
-            <a:pPr indent="0" marL="0">
-              <a:buNone/>
-            </a:pPr>
-            <a:r>
-              <a:rPr lang="en-US" sz="800" dirty="0">
-                <a:solidFill>
-                  <a:srgbClr val="4A5568"/>
-                </a:solidFill>
-                <a:latin typeface="Calibri" pitchFamily="34" charset="0"/>
-                <a:ea typeface="Calibri" pitchFamily="34" charset="-122"/>
-                <a:cs typeface="Calibri" pitchFamily="34" charset="-120"/>
-              </a:rPr>
-              <a:t>One chat across FLOW, COOCON and Bizplay with three kinds of product authentication. Writes refused until enabled, cross-organization lookups refused at the gateway, every step recorded.</a:t>
-            </a:r>
-            <a:endParaRPr lang="en-US" sz="800" dirty="0"/>
-          </a:p>
-        </p:txBody>
-      </p:sp>
-      <p:sp>
-        <p:nvSpPr>
-          <p:cNvPr id="23" name="Shape 20"/>
-          <p:cNvSpPr/>
-          <p:nvPr/>
-        </p:nvSpPr>
-        <p:spPr>
-          <a:xfrm>
-            <a:off x="4663440" y="3840480"/>
-            <a:ext cx="4069080" cy="841248"/>
-          </a:xfrm>
-          <a:prstGeom prst="roundRect">
-            <a:avLst>
-              <a:gd name="adj" fmla="val 6522"/>
-            </a:avLst>
-          </a:prstGeom>
-          <a:solidFill>
-            <a:srgbClr val="F5F7FA"/>
-          </a:solidFill>
-          <a:ln w="9525">
-            <a:solidFill>
-              <a:srgbClr val="D9E0EA"/>
-            </a:solidFill>
-            <a:prstDash val="solid"/>
-          </a:ln>
-        </p:spPr>
-      </p:sp>
-      <p:sp>
-        <p:nvSpPr>
-          <p:cNvPr id="24" name="Text 21"/>
-          <p:cNvSpPr txBox="1"/>
-          <p:nvPr/>
-        </p:nvSpPr>
-        <p:spPr>
-          <a:xfrm>
-            <a:off x="4818888" y="3904488"/>
-            <a:ext cx="3657600" cy="182880"/>
-          </a:xfrm>
-          <a:prstGeom prst="rect">
-            <a:avLst/>
-          </a:prstGeom>
-          <a:noFill/>
-          <a:ln/>
-        </p:spPr>
-        <p:txBody>
-          <a:bodyPr wrap="square" lIns="0" tIns="0" rIns="0" bIns="0" rtlCol="0" anchor="ctr"/>
-          <a:lstStyle/>
-          <a:p>
-            <a:pPr indent="0" marL="0">
-              <a:buNone/>
-            </a:pPr>
-            <a:r>
-              <a:rPr lang="en-US" sz="800" b="1" spc="100" kern="0" dirty="0">
-                <a:solidFill>
-                  <a:srgbClr val="B45309"/>
-                </a:solidFill>
-                <a:latin typeface="Calibri" pitchFamily="34" charset="0"/>
-                <a:ea typeface="Calibri" pitchFamily="34" charset="-122"/>
-                <a:cs typeface="Calibri" pitchFamily="34" charset="-120"/>
-              </a:rPr>
-              <a:t>WHAT IT DOES NOT YET SHOW</a:t>
-            </a:r>
-            <a:endParaRPr lang="en-US" sz="800" dirty="0"/>
-          </a:p>
-        </p:txBody>
-      </p:sp>
-      <p:sp>
-        <p:nvSpPr>
-          <p:cNvPr id="25" name="Text 22"/>
-          <p:cNvSpPr txBox="1"/>
-          <p:nvPr/>
-        </p:nvSpPr>
-        <p:spPr>
-          <a:xfrm>
-            <a:off x="4818888" y="4096512"/>
-            <a:ext cx="3749040" cy="548640"/>
-          </a:xfrm>
-          <a:prstGeom prst="rect">
-            <a:avLst/>
-          </a:prstGeom>
-          <a:noFill/>
-          <a:ln/>
-        </p:spPr>
-        <p:txBody>
-          <a:bodyPr wrap="square" lIns="0" tIns="0" rIns="0" bIns="0" rtlCol="0" anchor="ctr"/>
-          <a:lstStyle/>
-          <a:p>
-            <a:pPr indent="0" marL="0">
-              <a:buNone/>
-            </a:pPr>
-            <a:r>
-              <a:rPr lang="en-US" sz="800" dirty="0">
-                <a:solidFill>
-                  <a:srgbClr val="4A5568"/>
-                </a:solidFill>
-                <a:latin typeface="Calibri" pitchFamily="34" charset="0"/>
-                <a:ea typeface="Calibri" pitchFamily="34" charset="-122"/>
-                <a:cs typeface="Calibri" pitchFamily="34" charset="-120"/>
-              </a:rPr>
-              <a:t>Group single sign-on, approval-line integration for payments, operation at production scale, and results with real customer departments. These are the proposed work on the next slide.</a:t>
-            </a:r>
-            <a:endParaRPr lang="en-US" sz="800" dirty="0"/>
-          </a:p>
-        </p:txBody>
-      </p:sp>
-      <p:sp>
-        <p:nvSpPr>
-          <p:cNvPr id="26" name="Text 23"/>
+          <p:cNvPr id="29" name="Text 24"/>
           <p:cNvSpPr txBox="1"/>
           <p:nvPr/>
         </p:nvSpPr>
@@ -10193,7 +10225,7 @@
       </p:sp>
       <p:sp>
         <p:nvSpPr>
-          <p:cNvPr id="27" name="Text 24"/>
+          <p:cNvPr id="30" name="Text 25"/>
           <p:cNvSpPr txBox="1"/>
           <p:nvPr/>
         </p:nvSpPr>

</xml_diff>

<commit_message>
docs: proofread both concept decks
Co-Authored-By: Claude Fable 5.1 <noreply@anthropic.com>
</commit_message>
<xml_diff>
--- a/docs/webcash-ai-gateway-concept-visual.pptx
+++ b/docs/webcash-ai-gateway-concept-visual.pptx
@@ -2983,7 +2983,7 @@
                 <a:ea typeface="Calibri" pitchFamily="34" charset="-122"/>
                 <a:cs typeface="Calibri" pitchFamily="34" charset="-120"/>
               </a:rPr>
-              <a:t>Federating that sign-in page to the group's SSO is the production step.</a:t>
+              <a:t>Federating that sign-in page with the group's single sign-on (SSO) is proposed work.</a:t>
             </a:r>
             <a:endParaRPr lang="en-US" sz="880" dirty="0"/>
           </a:p>
@@ -4658,7 +4658,7 @@
                 <a:ea typeface="Calibri" pitchFamily="34" charset="-122"/>
                 <a:cs typeface="Calibri" pitchFamily="34" charset="-120"/>
               </a:rPr>
-              <a:t>Three ways to expose the same registry: shared catalogue /mcp · package /mcp/&lt;group&gt; · single product /mcp/&lt;product&gt;. All are routing decisions in one process.</a:t>
+              <a:t>Three ways to expose the same registry: shared catalog /mcp · package /mcp/&lt;group&gt; · single product /mcp/&lt;product&gt;. All are routing decisions in one process.</a:t>
             </a:r>
             <a:endParaRPr lang="en-US" sz="750" dirty="0"/>
           </a:p>
@@ -5509,7 +5509,7 @@
                 <a:ea typeface="Calibri" pitchFamily="34" charset="-122"/>
                 <a:cs typeface="Calibri" pitchFamily="34" charset="-120"/>
               </a:rPr>
-              <a:t>Existing controls stay the controls.</a:t>
+              <a:t>Existing approval lines stay in charge.</a:t>
             </a:r>
             <a:endParaRPr lang="en-US" sz="800" dirty="0"/>
           </a:p>
@@ -6601,7 +6601,7 @@
                 <a:ea typeface="Calibri" pitchFamily="34" charset="-122"/>
                 <a:cs typeface="Calibri" pitchFamily="34" charset="-120"/>
               </a:rPr>
-              <a:t>Each package is a set of products activated together. These are the use cases we propose; each one is delivered through the same registry and control model.</a:t>
+              <a:t>Each package is a set of products activated together and delivered through the same registry and control model.</a:t>
             </a:r>
             <a:endParaRPr lang="en-US" sz="1100" dirty="0"/>
           </a:p>
@@ -7646,7 +7646,7 @@
                           <a:ea typeface="Calibri" pitchFamily="34" charset="-122"/>
                           <a:cs typeface="Calibri" pitchFamily="34" charset="-120"/>
                         </a:rPr>
-                        <a:t>Approval-based</a:t>
+                        <a:t>Lookup · Approval line</a:t>
                       </a:r>
                       <a:endParaRPr lang="en-US" sz="830" dirty="0">
                         <a:latin typeface="Calibri" charset="0"/>
@@ -7908,7 +7908,7 @@
                           <a:ea typeface="Calibri" pitchFamily="34" charset="-122"/>
                           <a:cs typeface="Calibri" pitchFamily="34" charset="-120"/>
                         </a:rPr>
-                        <a:t>High control · Rules</a:t>
+                        <a:t>Lookup · Draft · Rule check</a:t>
                       </a:r>
                       <a:endParaRPr lang="en-US" sz="830" dirty="0">
                         <a:latin typeface="Calibri" charset="0"/>
@@ -10178,7 +10178,7 @@
                 <a:ea typeface="Calibri" pitchFamily="34" charset="-122"/>
                 <a:cs typeface="Calibri" pitchFamily="34" charset="-120"/>
               </a:rPr>
-              <a:t>A prototype built with the AI Convergence Lab confirmed all three choices with four products and two assistants. The open risks are group single sign-on, approval-line integration, production scale and validation with real customer departments. They are the proposed work on the next slide.</a:t>
+              <a:t>A prototype built with the AI Convergence Lab confirmed all three choices with four products and two assistants. The open risks are group single sign-on, approval-line integration, production scale and validation with real customer departments. The proposed work on the next slide addresses them.</a:t>
             </a:r>
             <a:endParaRPr lang="en-US" sz="850" dirty="0"/>
           </a:p>
@@ -11026,7 +11026,7 @@
                 <a:ea typeface="Calibri" pitchFamily="34" charset="-122"/>
                 <a:cs typeface="Calibri" pitchFamily="34" charset="-120"/>
               </a:rPr>
-              <a:t>Tool selection accuracy as the catalogue passes 100 tools: curated descriptions vs retrieval</a:t>
+              <a:t>Tool selection accuracy as the catalog passes 100 tools: curated descriptions versus retrieval</a:t>
             </a:r>
             <a:endParaRPr lang="en-US" sz="850" dirty="0"/>
           </a:p>
@@ -11047,7 +11047,7 @@
                 <a:ea typeface="Calibri" pitchFamily="34" charset="-122"/>
                 <a:cs typeface="Calibri" pitchFamily="34" charset="-120"/>
               </a:rPr>
-              <a:t>Verifiable policy for agents, not only enforced</a:t>
+              <a:t>Policy that can be verified, not only enforced</a:t>
             </a:r>
             <a:endParaRPr lang="en-US" sz="850" dirty="0"/>
           </a:p>
@@ -12040,7 +12040,7 @@
                 <a:ea typeface="Calibri" pitchFamily="34" charset="-122"/>
                 <a:cs typeface="Calibri" pitchFamily="34" charset="-120"/>
               </a:rPr>
-              <a:t>Every product would need its own AI integration, per AI vendor. Seven products times three assistants is twenty-one projects, each with its own auth and its own drift.</a:t>
+              <a:t>Every product would need its own AI integration, per AI vendor. Every product and assistant pair becomes a separate project, each with its own authentication and its own drift.</a:t>
             </a:r>
             <a:endParaRPr lang="en-US" sz="950" dirty="0"/>
           </a:p>
@@ -12348,7 +12348,7 @@
                 <a:ea typeface="Calibri" pitchFamily="34" charset="-122"/>
                 <a:cs typeface="Calibri" pitchFamily="34" charset="-120"/>
               </a:rPr>
-              <a:t>Nothing decides which actions an assistant may take, whether a change needs confirmation, or keeps a record a finance auditor would accept.</a:t>
+              <a:t>Nothing decides which actions an assistant may take or whether a change needs confirmation, and nothing keeps a record a finance auditor would accept.</a:t>
             </a:r>
             <a:endParaRPr lang="en-US" sz="950" dirty="0"/>
           </a:p>
@@ -13333,7 +13333,7 @@
                 <a:ea typeface="Calibri" pitchFamily="34" charset="-122"/>
                 <a:cs typeface="Calibri" pitchFamily="34" charset="-120"/>
               </a:rPr>
-              <a:t>The customer signs in once, through the gateway. Every call carries who they are and which organization.</a:t>
+              <a:t>The customer signs in once, through the gateway. Every call carries who they are and their organization.</a:t>
             </a:r>
             <a:endParaRPr lang="en-US" sz="720" dirty="0"/>
           </a:p>
@@ -14716,7 +14716,7 @@
                 <a:ea typeface="Calibri" pitchFamily="34" charset="-122"/>
                 <a:cs typeface="Calibri" pitchFamily="34" charset="-120"/>
               </a:rPr>
-              <a:t>The only screen the gateway ever shows a customer. After it, every product is just a tool inside their assistant.</a:t>
+              <a:t>This is the only screen the gateway ever shows a customer. After it, every product is just a tool inside their assistant.</a:t>
             </a:r>
             <a:endParaRPr lang="en-US" sz="1100" dirty="0"/>
           </a:p>
@@ -14901,7 +14901,7 @@
                 <a:ea typeface="Calibri" pitchFamily="34" charset="-122"/>
                 <a:cs typeface="Calibri" pitchFamily="34" charset="-120"/>
               </a:rPr>
-              <a:t>In claude.ai or ChatGPT: paste one address. The assistant discovers the gateway's sign-in on its own; no client ids, no tokens.</a:t>
+              <a:t>In claude.ai or ChatGPT: paste one address. The assistant discovers the gateway's sign-in on its own; no client IDs, no tokens.</a:t>
             </a:r>
             <a:endParaRPr lang="en-US" sz="800" dirty="0"/>
           </a:p>
@@ -15028,7 +15028,7 @@
                 <a:ea typeface="Calibri" pitchFamily="34" charset="-122"/>
                 <a:cs typeface="Calibri" pitchFamily="34" charset="-120"/>
               </a:rPr>
-              <a:t>It names the assistant and the gateway asking. The customer signs in with their company account. Admin accounts are refused: an assistant acts as a person.</a:t>
+              <a:t>It names the assistant and the gateway it is asking for. The customer signs in with their company account. Admin accounts are refused.</a:t>
             </a:r>
             <a:endParaRPr lang="en-US" sz="800" dirty="0"/>
           </a:p>
@@ -16905,7 +16905,7 @@
                 <a:ea typeface="Calibri" pitchFamily="34" charset="-122"/>
                 <a:cs typeface="Calibri" pitchFamily="34" charset="-120"/>
               </a:rPr>
-              <a:t>OAuth per user, a login endpoint with username and password, a service token, or open. The gateway does the rest at call time.</a:t>
+              <a:t>OAuth per user, a login endpoint with username and password, a service token, or none. The gateway does the rest at call time.</a:t>
             </a:r>
             <a:endParaRPr lang="en-US" sz="800" dirty="0"/>
           </a:p>
@@ -17872,7 +17872,7 @@
                 <a:ea typeface="Calibri" pitchFamily="34" charset="-122"/>
                 <a:cs typeface="Calibri" pitchFamily="34" charset="-120"/>
               </a:rPr>
-              <a:t>Tools on, out of tools generated</a:t>
+              <a:t>Tools enabled, out of those generated</a:t>
             </a:r>
             <a:endParaRPr lang="en-US" sz="1050" dirty="0"/>
           </a:p>
@@ -18195,7 +18195,7 @@
                 <a:ea typeface="Calibri" pitchFamily="34" charset="-122"/>
                 <a:cs typeface="Calibri" pitchFamily="34" charset="-120"/>
               </a:rPr>
-              <a:t>The shared catalogue, two customer packages, and the product's own MCP server. Publishing to one is a routing change, not a release.</a:t>
+              <a:t>The shared catalog, two customer packages, and the product's own MCP server. Publishing to one is a routing change, not a release.</a:t>
             </a:r>
             <a:endParaRPr lang="en-US" sz="800" dirty="0"/>
           </a:p>
@@ -19679,7 +19679,7 @@
                 <a:ea typeface="Calibri" pitchFamily="34" charset="-122"/>
                 <a:cs typeface="Calibri" pitchFamily="34" charset="-120"/>
               </a:rPr>
-              <a:t>Measured on the running system: a write refused with “tool is disabled”, a cross-organization lookup refused before it left the gateway, and a chain across four products in one chat. Each is one line in the audit log.</a:t>
+              <a:t>Observed in the prototype: a write refused with “tool is disabled”, a cross-organization lookup refused before it left the gateway, and a chain across four products in one chat. Each is one line in the audit log.</a:t>
             </a:r>
             <a:endParaRPr lang="en-US" sz="900" dirty="0"/>
           </a:p>
@@ -21157,7 +21157,7 @@
                 <a:ea typeface="Calibri" pitchFamily="34" charset="-122"/>
                 <a:cs typeface="Calibri" pitchFamily="34" charset="-120"/>
               </a:rPr>
-              <a:t>OpenAPI spec, any auth</a:t>
+              <a:t>OpenAPI spec, any authentication</a:t>
             </a:r>
             <a:endParaRPr lang="en-US" sz="680" dirty="0"/>
           </a:p>
@@ -21561,7 +21561,7 @@
                 <a:ea typeface="Calibri" pitchFamily="34" charset="-122"/>
                 <a:cs typeface="Calibri" pitchFamily="34" charset="-120"/>
               </a:rPr>
-              <a:t>Runs as one container image behind HTTPS; deploying or exposing a product is a routing change, not a release. Per-product isolation is on the roadmap.</a:t>
+              <a:t>Runs as one container image behind HTTPS; deploying or exposing a product is a routing change, not a release. Per-product isolation is part of the proposed work.</a:t>
             </a:r>
             <a:endParaRPr lang="en-US" sz="800" dirty="0"/>
           </a:p>

</xml_diff>